<commit_message>
update template.pptx with new slide design and content
</commit_message>
<xml_diff>
--- a/template/template.pptx
+++ b/template/template.pptx
@@ -16,8 +16,8 @@
 </file>
 
 <file path=ppt/slideLayouts/slideLayout1.xml><?xml version="1.0" encoding="utf-8"?>
-<p:sldLayout xmlns:a="http://schemas.openxmlformats.org/drawingml/2006/main" xmlns:p="http://schemas.openxmlformats.org/presentationml/2006/main" xmlns:r="http://schemas.openxmlformats.org/officeDocument/2006/relationships" xmlns:p14="http://schemas.microsoft.com/office/powerpoint/2010/main" xmlns:p15="http://schemas.microsoft.com/office/powerpoint/2012/main" xmlns:mc="http://schemas.openxmlformats.org/markup-compatibility/2006" type="obj" preserve="1">
-  <p:cSld name="Title and Content">
+<p:sldLayout xmlns:a="http://schemas.openxmlformats.org/drawingml/2006/main" xmlns:p="http://schemas.openxmlformats.org/presentationml/2006/main" xmlns:r="http://schemas.openxmlformats.org/officeDocument/2006/relationships" xmlns:p14="http://schemas.microsoft.com/office/powerpoint/2010/main" xmlns:p15="http://schemas.microsoft.com/office/powerpoint/2012/main" xmlns:mc="http://schemas.openxmlformats.org/markup-compatibility/2006" type="vertTitleAndTx" preserve="1">
+  <p:cSld name="Vertical Title and Text">
     <p:bg>
       <p:bgPr>
         <a:solidFill>
@@ -51,8 +51,8 @@
         </p:nvSpPr>
         <p:spPr>
           <a:xfrm>
-            <a:off x="457200" y="274680"/>
-            <a:ext cx="8225640" cy="1139040"/>
+            <a:off x="6629400" y="274680"/>
+            <a:ext cx="2052000" cy="5846040"/>
           </a:xfrm>
           <a:prstGeom prst="rect">
             <a:avLst/>
@@ -63,7 +63,7 @@
           </a:ln>
         </p:spPr>
         <p:txBody>
-          <a:bodyPr lIns="91440" tIns="45720" rIns="91440" bIns="45720" anchor="ctr">
+          <a:bodyPr lIns="91440" tIns="45720" rIns="91440" bIns="45720" anchor="ctr" vert="eaVert">
             <a:noAutofit/>
           </a:bodyPr>
           <a:lstStyle>
@@ -104,51 +104,7 @@
                 <a:uFillTx/>
                 <a:latin typeface="Calibri"/>
               </a:rPr>
-              <a:t>Click to </a:t>
-            </a:r>
-            <a:r>
-              <a:rPr lang="en-US" sz="4400" b="0" u="none" strike="noStrike">
-                <a:solidFill>
-                  <a:schemeClr val="dk1"/>
-                </a:solidFill>
-                <a:effectLst/>
-                <a:uFillTx/>
-                <a:latin typeface="Calibri"/>
-              </a:rPr>
-              <a:t>edit </a:t>
-            </a:r>
-            <a:r>
-              <a:rPr lang="en-US" sz="4400" b="0" u="none" strike="noStrike">
-                <a:solidFill>
-                  <a:schemeClr val="dk1"/>
-                </a:solidFill>
-                <a:effectLst/>
-                <a:uFillTx/>
-                <a:latin typeface="Calibri"/>
-              </a:rPr>
-              <a:t>Master </a:t>
-            </a:r>
-            <a:r>
-              <a:rPr lang="en-US" sz="4400" b="0" u="none" strike="noStrike">
-                <a:solidFill>
-                  <a:schemeClr val="dk1"/>
-                </a:solidFill>
-                <a:effectLst/>
-                <a:uFillTx/>
-                <a:latin typeface="Calibri"/>
-              </a:rPr>
-              <a:t>title </a:t>
-            </a:r>
-            <a:r>
-              <a:rPr lang="en-US" sz="4400" b="0" u="none" strike="noStrike">
-                <a:solidFill>
-                  <a:schemeClr val="dk1"/>
-                </a:solidFill>
-                <a:effectLst/>
-                <a:uFillTx/>
-                <a:latin typeface="Calibri"/>
-              </a:rPr>
-              <a:t>style</a:t>
+              <a:t>Click to edit Master title style</a:t>
             </a:r>
             <a:endParaRPr lang="en-US" sz="4400" b="0" u="none" strike="noStrike">
               <a:solidFill>
@@ -173,8 +129,8 @@
         </p:nvSpPr>
         <p:spPr>
           <a:xfrm>
-            <a:off x="457200" y="1600200"/>
-            <a:ext cx="8225640" cy="4521960"/>
+            <a:off x="457200" y="274680"/>
+            <a:ext cx="6014520" cy="5846040"/>
           </a:xfrm>
           <a:prstGeom prst="rect">
             <a:avLst/>
@@ -185,7 +141,7 @@
           </a:ln>
         </p:spPr>
         <p:txBody>
-          <a:bodyPr lIns="91440" tIns="45720" rIns="91440" bIns="45720" anchor="t">
+          <a:bodyPr lIns="91440" tIns="45720" rIns="91440" bIns="45720" anchor="t" vert="eaVert">
             <a:noAutofit/>
           </a:bodyPr>
           <a:lstStyle>
@@ -480,7 +436,7 @@
         <p:spPr>
           <a:xfrm>
             <a:off x="457200" y="6356520"/>
-            <a:ext cx="2129760" cy="361080"/>
+            <a:ext cx="2128320" cy="359640"/>
           </a:xfrm>
           <a:prstGeom prst="rect">
             <a:avLst/>
@@ -536,7 +492,7 @@
                 <a:uFillTx/>
                 <a:latin typeface="Calibri"/>
               </a:rPr>
-              <a:t>&lt;date/time&gt;</a:t>
+              <a:t> </a:t>
             </a:r>
             <a:endParaRPr lang="en-US" sz="1200" b="0" u="none" strike="noStrike">
               <a:solidFill>
@@ -562,7 +518,7 @@
         <p:spPr>
           <a:xfrm>
             <a:off x="3124080" y="6356520"/>
-            <a:ext cx="2891520" cy="361080"/>
+            <a:ext cx="2890080" cy="359640"/>
           </a:xfrm>
           <a:prstGeom prst="rect">
             <a:avLst/>
@@ -614,7 +570,7 @@
                 <a:uFillTx/>
                 <a:latin typeface="Times New Roman"/>
               </a:rPr>
-              <a:t>&lt;footer&gt;</a:t>
+              <a:t> </a:t>
             </a:r>
             <a:endParaRPr lang="en-US" sz="1400" b="0" u="none" strike="noStrike">
               <a:solidFill>
@@ -640,7 +596,7 @@
         <p:spPr>
           <a:xfrm>
             <a:off x="6553080" y="6356520"/>
-            <a:ext cx="2129760" cy="361080"/>
+            <a:ext cx="2128320" cy="359640"/>
           </a:xfrm>
           <a:prstGeom prst="rect">
             <a:avLst/>
@@ -685,7 +641,7 @@
                 <a:tab pos="0" algn="l"/>
               </a:tabLst>
             </a:pPr>
-            <a:fld id="{2F540D96-455C-44F4-93A0-1787E8054F4C}" type="slidenum">
+            <a:fld id="{425822A3-CEA0-4F98-B4EB-FD1A0C905A48}" type="slidenum">
               <a:rPr lang="en-US" sz="1200" b="0" u="none" strike="noStrike">
                 <a:solidFill>
                   <a:schemeClr val="dk1">
@@ -696,7 +652,7 @@
                 <a:uFillTx/>
                 <a:latin typeface="Calibri"/>
               </a:rPr>
-              <a:t>&lt;number&gt;</a:t>
+              <a:t>3</a:t>
             </a:fld>
             <a:endParaRPr lang="en-US" sz="1200" b="0" u="none" strike="noStrike">
               <a:solidFill>
@@ -715,8 +671,8 @@
 </file>
 
 <file path=ppt/slideLayouts/slideLayout10.xml><?xml version="1.0" encoding="utf-8"?>
-<p:sldLayout xmlns:a="http://schemas.openxmlformats.org/drawingml/2006/main" xmlns:p="http://schemas.openxmlformats.org/presentationml/2006/main" xmlns:r="http://schemas.openxmlformats.org/officeDocument/2006/relationships" xmlns:p14="http://schemas.microsoft.com/office/powerpoint/2010/main" xmlns:p15="http://schemas.microsoft.com/office/powerpoint/2012/main" xmlns:mc="http://schemas.openxmlformats.org/markup-compatibility/2006" type="vertTx" preserve="1">
-  <p:cSld name="Title and Vertical Text">
+<p:sldLayout xmlns:a="http://schemas.openxmlformats.org/drawingml/2006/main" xmlns:p="http://schemas.openxmlformats.org/presentationml/2006/main" xmlns:r="http://schemas.openxmlformats.org/officeDocument/2006/relationships" xmlns:p14="http://schemas.microsoft.com/office/powerpoint/2010/main" xmlns:p15="http://schemas.microsoft.com/office/powerpoint/2012/main" xmlns:mc="http://schemas.openxmlformats.org/markup-compatibility/2006" type="title" preserve="1">
+  <p:cSld name="Title Slide">
     <p:bg>
       <p:bgPr>
         <a:solidFill>
@@ -740,7 +696,7 @@
       </p:grpSpPr>
       <p:sp>
         <p:nvSpPr>
-          <p:cNvPr id="51" name="PlaceHolder 1"/>
+          <p:cNvPr id="52" name="PlaceHolder 1"/>
           <p:cNvSpPr>
             <a:spLocks noGrp="1"/>
           </p:cNvSpPr>
@@ -750,8 +706,8 @@
         </p:nvSpPr>
         <p:spPr>
           <a:xfrm>
-            <a:off x="457200" y="274680"/>
-            <a:ext cx="8225640" cy="1139040"/>
+            <a:off x="685800" y="2130480"/>
+            <a:ext cx="7767000" cy="1464480"/>
           </a:xfrm>
           <a:prstGeom prst="rect">
             <a:avLst/>
@@ -818,313 +774,7 @@
       </p:sp>
       <p:sp>
         <p:nvSpPr>
-          <p:cNvPr id="52" name="PlaceHolder 2"/>
-          <p:cNvSpPr>
-            <a:spLocks noGrp="1"/>
-          </p:cNvSpPr>
-          <p:nvPr>
-            <p:ph type="body"/>
-          </p:nvPr>
-        </p:nvSpPr>
-        <p:spPr>
-          <a:xfrm>
-            <a:off x="457200" y="1600200"/>
-            <a:ext cx="8225640" cy="4521960"/>
-          </a:xfrm>
-          <a:prstGeom prst="rect">
-            <a:avLst/>
-          </a:prstGeom>
-          <a:noFill/>
-          <a:ln w="0">
-            <a:noFill/>
-          </a:ln>
-        </p:spPr>
-        <p:txBody>
-          <a:bodyPr lIns="91440" tIns="45720" rIns="91440" bIns="45720" anchor="t" vert="eaVert">
-            <a:noAutofit/>
-          </a:bodyPr>
-          <a:lstStyle>
-            <a:lvl1pPr algn="l" defTabSz="457200">
-              <a:lnSpc>
-                <a:spcPct val="100000"/>
-              </a:lnSpc>
-              <a:spcBef>
-                <a:spcPts val="641"/>
-              </a:spcBef>
-              <a:buClr>
-                <a:srgbClr val="000000"/>
-              </a:buClr>
-              <a:buFont typeface="Arial"/>
-              <a:buChar char="•"/>
-              <a:defRPr lang="en-US" sz="3200" b="0" u="none" strike="noStrike">
-                <a:solidFill>
-                  <a:schemeClr val="dk1"/>
-                </a:solidFill>
-                <a:effectLst/>
-                <a:uFillTx/>
-                <a:latin typeface="Calibri"/>
-              </a:defRPr>
-            </a:lvl1pPr>
-            <a:lvl2pPr lvl="1" algn="l" defTabSz="457200">
-              <a:lnSpc>
-                <a:spcPct val="100000"/>
-              </a:lnSpc>
-              <a:spcBef>
-                <a:spcPts val="561"/>
-              </a:spcBef>
-              <a:buClr>
-                <a:srgbClr val="000000"/>
-              </a:buClr>
-              <a:buFont typeface="Arial"/>
-              <a:buChar char="–"/>
-              <a:defRPr lang="en-US" sz="2800" b="0" u="none" strike="noStrike">
-                <a:solidFill>
-                  <a:schemeClr val="dk1"/>
-                </a:solidFill>
-                <a:effectLst/>
-                <a:uFillTx/>
-                <a:latin typeface="Calibri"/>
-              </a:defRPr>
-            </a:lvl2pPr>
-            <a:lvl3pPr lvl="2" algn="l" defTabSz="457200">
-              <a:lnSpc>
-                <a:spcPct val="100000"/>
-              </a:lnSpc>
-              <a:spcBef>
-                <a:spcPts val="479"/>
-              </a:spcBef>
-              <a:buClr>
-                <a:srgbClr val="000000"/>
-              </a:buClr>
-              <a:buFont typeface="Arial"/>
-              <a:buChar char="•"/>
-              <a:defRPr lang="en-US" sz="2400" b="0" u="none" strike="noStrike">
-                <a:solidFill>
-                  <a:schemeClr val="dk1"/>
-                </a:solidFill>
-                <a:effectLst/>
-                <a:uFillTx/>
-                <a:latin typeface="Calibri"/>
-              </a:defRPr>
-            </a:lvl3pPr>
-            <a:lvl4pPr lvl="3" algn="l" defTabSz="457200">
-              <a:lnSpc>
-                <a:spcPct val="100000"/>
-              </a:lnSpc>
-              <a:spcBef>
-                <a:spcPts val="400"/>
-              </a:spcBef>
-              <a:buClr>
-                <a:srgbClr val="000000"/>
-              </a:buClr>
-              <a:buFont typeface="Arial"/>
-              <a:buChar char="–"/>
-              <a:defRPr lang="en-US" sz="2000" b="0" u="none" strike="noStrike">
-                <a:solidFill>
-                  <a:schemeClr val="dk1"/>
-                </a:solidFill>
-                <a:effectLst/>
-                <a:uFillTx/>
-                <a:latin typeface="Calibri"/>
-              </a:defRPr>
-            </a:lvl4pPr>
-            <a:lvl5pPr lvl="4" algn="l" defTabSz="457200">
-              <a:lnSpc>
-                <a:spcPct val="100000"/>
-              </a:lnSpc>
-              <a:spcBef>
-                <a:spcPts val="400"/>
-              </a:spcBef>
-              <a:buClr>
-                <a:srgbClr val="000000"/>
-              </a:buClr>
-              <a:buFont typeface="Arial"/>
-              <a:buChar char="»"/>
-              <a:defRPr lang="en-US" sz="2000" b="0" u="none" strike="noStrike">
-                <a:solidFill>
-                  <a:schemeClr val="dk1"/>
-                </a:solidFill>
-                <a:effectLst/>
-                <a:uFillTx/>
-                <a:latin typeface="Calibri"/>
-              </a:defRPr>
-            </a:lvl5pPr>
-          </a:lstStyle>
-          <a:p>
-            <a:pPr marL="343080" indent="-343080" algn="l" defTabSz="457200">
-              <a:lnSpc>
-                <a:spcPct val="100000"/>
-              </a:lnSpc>
-              <a:spcBef>
-                <a:spcPts val="641"/>
-              </a:spcBef>
-              <a:buClr>
-                <a:srgbClr val="000000"/>
-              </a:buClr>
-              <a:buFont typeface="Arial"/>
-              <a:buChar char="•"/>
-            </a:pPr>
-            <a:r>
-              <a:rPr lang="en-US" sz="3200" b="0" u="none" strike="noStrike">
-                <a:solidFill>
-                  <a:schemeClr val="dk1"/>
-                </a:solidFill>
-                <a:effectLst/>
-                <a:uFillTx/>
-                <a:latin typeface="Calibri"/>
-              </a:rPr>
-              <a:t>Click to edit Master text styles</a:t>
-            </a:r>
-            <a:endParaRPr lang="en-US" sz="3200" b="0" u="none" strike="noStrike">
-              <a:solidFill>
-                <a:schemeClr val="dk1"/>
-              </a:solidFill>
-              <a:effectLst/>
-              <a:uFillTx/>
-              <a:latin typeface="Calibri"/>
-            </a:endParaRPr>
-          </a:p>
-          <a:p>
-            <a:pPr marL="743040" lvl="1" indent="-285840" algn="l" defTabSz="457200">
-              <a:lnSpc>
-                <a:spcPct val="100000"/>
-              </a:lnSpc>
-              <a:spcBef>
-                <a:spcPts val="561"/>
-              </a:spcBef>
-              <a:buClr>
-                <a:srgbClr val="000000"/>
-              </a:buClr>
-              <a:buFont typeface="Arial"/>
-              <a:buChar char="–"/>
-            </a:pPr>
-            <a:r>
-              <a:rPr lang="en-US" sz="2800" b="0" u="none" strike="noStrike">
-                <a:solidFill>
-                  <a:schemeClr val="dk1"/>
-                </a:solidFill>
-                <a:effectLst/>
-                <a:uFillTx/>
-                <a:latin typeface="Calibri"/>
-              </a:rPr>
-              <a:t>Second level</a:t>
-            </a:r>
-            <a:endParaRPr lang="en-US" sz="2800" b="0" u="none" strike="noStrike">
-              <a:solidFill>
-                <a:schemeClr val="dk1"/>
-              </a:solidFill>
-              <a:effectLst/>
-              <a:uFillTx/>
-              <a:latin typeface="Calibri"/>
-            </a:endParaRPr>
-          </a:p>
-          <a:p>
-            <a:pPr marL="1143000" lvl="2" indent="-228600" algn="l" defTabSz="457200">
-              <a:lnSpc>
-                <a:spcPct val="100000"/>
-              </a:lnSpc>
-              <a:spcBef>
-                <a:spcPts val="479"/>
-              </a:spcBef>
-              <a:buClr>
-                <a:srgbClr val="000000"/>
-              </a:buClr>
-              <a:buFont typeface="Arial"/>
-              <a:buChar char="•"/>
-            </a:pPr>
-            <a:r>
-              <a:rPr lang="en-US" sz="2400" b="0" u="none" strike="noStrike">
-                <a:solidFill>
-                  <a:schemeClr val="dk1"/>
-                </a:solidFill>
-                <a:effectLst/>
-                <a:uFillTx/>
-                <a:latin typeface="Calibri"/>
-              </a:rPr>
-              <a:t>Third level</a:t>
-            </a:r>
-            <a:endParaRPr lang="en-US" sz="2400" b="0" u="none" strike="noStrike">
-              <a:solidFill>
-                <a:schemeClr val="dk1"/>
-              </a:solidFill>
-              <a:effectLst/>
-              <a:uFillTx/>
-              <a:latin typeface="Calibri"/>
-            </a:endParaRPr>
-          </a:p>
-          <a:p>
-            <a:pPr marL="1600200" lvl="3" indent="-228600" algn="l" defTabSz="457200">
-              <a:lnSpc>
-                <a:spcPct val="100000"/>
-              </a:lnSpc>
-              <a:spcBef>
-                <a:spcPts val="400"/>
-              </a:spcBef>
-              <a:buClr>
-                <a:srgbClr val="000000"/>
-              </a:buClr>
-              <a:buFont typeface="Arial"/>
-              <a:buChar char="–"/>
-            </a:pPr>
-            <a:r>
-              <a:rPr lang="en-US" sz="2000" b="0" u="none" strike="noStrike">
-                <a:solidFill>
-                  <a:schemeClr val="dk1"/>
-                </a:solidFill>
-                <a:effectLst/>
-                <a:uFillTx/>
-                <a:latin typeface="Calibri"/>
-              </a:rPr>
-              <a:t>Fourth level</a:t>
-            </a:r>
-            <a:endParaRPr lang="en-US" sz="2000" b="0" u="none" strike="noStrike">
-              <a:solidFill>
-                <a:schemeClr val="dk1"/>
-              </a:solidFill>
-              <a:effectLst/>
-              <a:uFillTx/>
-              <a:latin typeface="Calibri"/>
-            </a:endParaRPr>
-          </a:p>
-          <a:p>
-            <a:pPr marL="2057400" lvl="4" indent="-228600" algn="l" defTabSz="457200">
-              <a:lnSpc>
-                <a:spcPct val="100000"/>
-              </a:lnSpc>
-              <a:spcBef>
-                <a:spcPts val="400"/>
-              </a:spcBef>
-              <a:buClr>
-                <a:srgbClr val="000000"/>
-              </a:buClr>
-              <a:buFont typeface="Arial"/>
-              <a:buChar char="»"/>
-            </a:pPr>
-            <a:r>
-              <a:rPr lang="en-US" sz="2000" b="0" u="none" strike="noStrike">
-                <a:solidFill>
-                  <a:schemeClr val="dk1"/>
-                </a:solidFill>
-                <a:effectLst/>
-                <a:uFillTx/>
-                <a:latin typeface="Calibri"/>
-              </a:rPr>
-              <a:t>Fifth level</a:t>
-            </a:r>
-            <a:endParaRPr lang="en-US" sz="2000" b="0" u="none" strike="noStrike">
-              <a:solidFill>
-                <a:schemeClr val="dk1"/>
-              </a:solidFill>
-              <a:effectLst/>
-              <a:uFillTx/>
-              <a:latin typeface="Calibri"/>
-            </a:endParaRPr>
-          </a:p>
-        </p:txBody>
-      </p:sp>
-      <p:sp>
-        <p:nvSpPr>
-          <p:cNvPr id="53" name="PlaceHolder 3"/>
+          <p:cNvPr id="53" name="PlaceHolder 2"/>
           <p:cNvSpPr>
             <a:spLocks noGrp="1"/>
           </p:cNvSpPr>
@@ -1135,7 +785,7 @@
         <p:spPr>
           <a:xfrm>
             <a:off x="457200" y="6356520"/>
-            <a:ext cx="2129760" cy="361080"/>
+            <a:ext cx="2128320" cy="359640"/>
           </a:xfrm>
           <a:prstGeom prst="rect">
             <a:avLst/>
@@ -1206,7 +856,7 @@
       </p:sp>
       <p:sp>
         <p:nvSpPr>
-          <p:cNvPr id="54" name="PlaceHolder 4"/>
+          <p:cNvPr id="54" name="PlaceHolder 3"/>
           <p:cNvSpPr>
             <a:spLocks noGrp="1"/>
           </p:cNvSpPr>
@@ -1217,7 +867,7 @@
         <p:spPr>
           <a:xfrm>
             <a:off x="3124080" y="6356520"/>
-            <a:ext cx="2891520" cy="361080"/>
+            <a:ext cx="2890080" cy="359640"/>
           </a:xfrm>
           <a:prstGeom prst="rect">
             <a:avLst/>
@@ -1284,7 +934,7 @@
       </p:sp>
       <p:sp>
         <p:nvSpPr>
-          <p:cNvPr id="55" name="PlaceHolder 5"/>
+          <p:cNvPr id="55" name="PlaceHolder 4"/>
           <p:cNvSpPr>
             <a:spLocks noGrp="1"/>
           </p:cNvSpPr>
@@ -1295,7 +945,7 @@
         <p:spPr>
           <a:xfrm>
             <a:off x="6553080" y="6356520"/>
-            <a:ext cx="2129760" cy="361080"/>
+            <a:ext cx="2128320" cy="359640"/>
           </a:xfrm>
           <a:prstGeom prst="rect">
             <a:avLst/>
@@ -1340,7 +990,7 @@
                 <a:tab pos="0" algn="l"/>
               </a:tabLst>
             </a:pPr>
-            <a:fld id="{97DC50FC-11CD-4073-B0A6-396DAB844F99}" type="slidenum">
+            <a:fld id="{C896FE2A-1C02-4482-A3B8-A62CF837671B}" type="slidenum">
               <a:rPr lang="en-US" sz="1200" b="0" u="none" strike="noStrike">
                 <a:solidFill>
                   <a:schemeClr val="dk1">
@@ -1370,8 +1020,8 @@
 </file>
 
 <file path=ppt/slideLayouts/slideLayout11.xml><?xml version="1.0" encoding="utf-8"?>
-<p:sldLayout xmlns:a="http://schemas.openxmlformats.org/drawingml/2006/main" xmlns:p="http://schemas.openxmlformats.org/presentationml/2006/main" xmlns:r="http://schemas.openxmlformats.org/officeDocument/2006/relationships" xmlns:p14="http://schemas.microsoft.com/office/powerpoint/2010/main" xmlns:p15="http://schemas.microsoft.com/office/powerpoint/2012/main" xmlns:mc="http://schemas.openxmlformats.org/markup-compatibility/2006" type="vertTitleAndTx" preserve="1">
-  <p:cSld name="Vertical Title and Text">
+<p:sldLayout xmlns:a="http://schemas.openxmlformats.org/drawingml/2006/main" xmlns:p="http://schemas.openxmlformats.org/presentationml/2006/main" xmlns:r="http://schemas.openxmlformats.org/officeDocument/2006/relationships" xmlns:p14="http://schemas.microsoft.com/office/powerpoint/2010/main" xmlns:p15="http://schemas.microsoft.com/office/powerpoint/2012/main" xmlns:mc="http://schemas.openxmlformats.org/markup-compatibility/2006" type="vertTx" preserve="1">
+  <p:cSld name="Title and Vertical Text">
     <p:bg>
       <p:bgPr>
         <a:solidFill>
@@ -1405,8 +1055,8 @@
         </p:nvSpPr>
         <p:spPr>
           <a:xfrm>
-            <a:off x="6629400" y="274680"/>
-            <a:ext cx="2053440" cy="5847480"/>
+            <a:off x="457200" y="274680"/>
+            <a:ext cx="8224200" cy="1137600"/>
           </a:xfrm>
           <a:prstGeom prst="rect">
             <a:avLst/>
@@ -1417,7 +1067,7 @@
           </a:ln>
         </p:spPr>
         <p:txBody>
-          <a:bodyPr lIns="91440" tIns="45720" rIns="91440" bIns="45720" anchor="ctr" vert="eaVert">
+          <a:bodyPr lIns="91440" tIns="45720" rIns="91440" bIns="45720" anchor="ctr">
             <a:noAutofit/>
           </a:bodyPr>
           <a:lstStyle>
@@ -1483,8 +1133,8 @@
         </p:nvSpPr>
         <p:spPr>
           <a:xfrm>
-            <a:off x="457200" y="274680"/>
-            <a:ext cx="6015960" cy="5847480"/>
+            <a:off x="457200" y="1600200"/>
+            <a:ext cx="8224200" cy="4520520"/>
           </a:xfrm>
           <a:prstGeom prst="rect">
             <a:avLst/>
@@ -1790,7 +1440,7 @@
         <p:spPr>
           <a:xfrm>
             <a:off x="457200" y="6356520"/>
-            <a:ext cx="2129760" cy="361080"/>
+            <a:ext cx="2128320" cy="359640"/>
           </a:xfrm>
           <a:prstGeom prst="rect">
             <a:avLst/>
@@ -1872,7 +1522,7 @@
         <p:spPr>
           <a:xfrm>
             <a:off x="3124080" y="6356520"/>
-            <a:ext cx="2891520" cy="361080"/>
+            <a:ext cx="2890080" cy="359640"/>
           </a:xfrm>
           <a:prstGeom prst="rect">
             <a:avLst/>
@@ -1950,7 +1600,7 @@
         <p:spPr>
           <a:xfrm>
             <a:off x="6553080" y="6356520"/>
-            <a:ext cx="2129760" cy="361080"/>
+            <a:ext cx="2128320" cy="359640"/>
           </a:xfrm>
           <a:prstGeom prst="rect">
             <a:avLst/>
@@ -1995,7 +1645,7 @@
                 <a:tab pos="0" algn="l"/>
               </a:tabLst>
             </a:pPr>
-            <a:fld id="{1E66373D-C882-4500-A5D7-37FEA83C297F}" type="slidenum">
+            <a:fld id="{913EFF6F-1DEE-4DD9-B65B-6FC19D882F1F}" type="slidenum">
               <a:rPr lang="en-US" sz="1200" b="0" u="none" strike="noStrike">
                 <a:solidFill>
                   <a:schemeClr val="dk1">
@@ -2025,8 +1675,8 @@
 </file>
 
 <file path=ppt/slideLayouts/slideLayout2.xml><?xml version="1.0" encoding="utf-8"?>
-<p:sldLayout xmlns:a="http://schemas.openxmlformats.org/drawingml/2006/main" xmlns:p="http://schemas.openxmlformats.org/presentationml/2006/main" xmlns:r="http://schemas.openxmlformats.org/officeDocument/2006/relationships" xmlns:p14="http://schemas.microsoft.com/office/powerpoint/2010/main" xmlns:p15="http://schemas.microsoft.com/office/powerpoint/2012/main" xmlns:mc="http://schemas.openxmlformats.org/markup-compatibility/2006" type="blank" preserve="1">
-  <p:cSld name="Section Header">
+<p:sldLayout xmlns:a="http://schemas.openxmlformats.org/drawingml/2006/main" xmlns:p="http://schemas.openxmlformats.org/presentationml/2006/main" xmlns:r="http://schemas.openxmlformats.org/officeDocument/2006/relationships" xmlns:p14="http://schemas.microsoft.com/office/powerpoint/2010/main" xmlns:p15="http://schemas.microsoft.com/office/powerpoint/2012/main" xmlns:mc="http://schemas.openxmlformats.org/markup-compatibility/2006" type="obj" preserve="1">
+  <p:cSld name="Title and Content">
     <p:bg>
       <p:bgPr>
         <a:solidFill>
@@ -2060,8 +1710,86 @@
         </p:nvSpPr>
         <p:spPr>
           <a:xfrm>
-            <a:off x="722160" y="4406760"/>
-            <a:ext cx="7768440" cy="1358280"/>
+            <a:off x="457200" y="274680"/>
+            <a:ext cx="8224200" cy="1137600"/>
+          </a:xfrm>
+          <a:prstGeom prst="rect">
+            <a:avLst/>
+          </a:prstGeom>
+          <a:noFill/>
+          <a:ln w="0">
+            <a:noFill/>
+          </a:ln>
+        </p:spPr>
+        <p:txBody>
+          <a:bodyPr lIns="91440" tIns="45720" rIns="91440" bIns="45720" anchor="ctr">
+            <a:noAutofit/>
+          </a:bodyPr>
+          <a:lstStyle>
+            <a:lvl1pPr indent="0" algn="ctr" defTabSz="457200">
+              <a:lnSpc>
+                <a:spcPct val="100000"/>
+              </a:lnSpc>
+              <a:buNone/>
+              <a:tabLst>
+                <a:tab pos="0" algn="l"/>
+              </a:tabLst>
+              <a:defRPr lang="en-US" sz="4400" b="0" u="none" strike="noStrike">
+                <a:solidFill>
+                  <a:schemeClr val="dk1"/>
+                </a:solidFill>
+                <a:effectLst/>
+                <a:uFillTx/>
+                <a:latin typeface="Calibri"/>
+              </a:defRPr>
+            </a:lvl1pPr>
+          </a:lstStyle>
+          <a:p>
+            <a:pPr indent="0" algn="ctr" defTabSz="457200">
+              <a:lnSpc>
+                <a:spcPct val="100000"/>
+              </a:lnSpc>
+              <a:buNone/>
+              <a:tabLst>
+                <a:tab pos="0" algn="l"/>
+              </a:tabLst>
+            </a:pPr>
+            <a:r>
+              <a:rPr lang="en-US" sz="4400" b="0" u="none" strike="noStrike">
+                <a:solidFill>
+                  <a:schemeClr val="dk1"/>
+                </a:solidFill>
+                <a:effectLst/>
+                <a:uFillTx/>
+                <a:latin typeface="Calibri"/>
+              </a:rPr>
+              <a:t>Click to edit Master title style</a:t>
+            </a:r>
+            <a:endParaRPr lang="en-US" sz="4400" b="0" u="none" strike="noStrike">
+              <a:solidFill>
+                <a:schemeClr val="dk1"/>
+              </a:solidFill>
+              <a:effectLst/>
+              <a:uFillTx/>
+              <a:latin typeface="Calibri"/>
+            </a:endParaRPr>
+          </a:p>
+        </p:txBody>
+      </p:sp>
+      <p:sp>
+        <p:nvSpPr>
+          <p:cNvPr id="8" name="PlaceHolder 2"/>
+          <p:cNvSpPr>
+            <a:spLocks noGrp="1"/>
+          </p:cNvSpPr>
+          <p:nvPr>
+            <p:ph type="body"/>
+          </p:nvPr>
+        </p:nvSpPr>
+        <p:spPr>
+          <a:xfrm>
+            <a:off x="457200" y="1600200"/>
+            <a:ext cx="8224200" cy="4520520"/>
           </a:xfrm>
           <a:prstGeom prst="rect">
             <a:avLst/>
@@ -2076,15 +1804,19 @@
             <a:noAutofit/>
           </a:bodyPr>
           <a:lstStyle>
-            <a:lvl1pPr indent="0" algn="l" defTabSz="457200">
-              <a:lnSpc>
-                <a:spcPct val="100000"/>
-              </a:lnSpc>
-              <a:buNone/>
-              <a:tabLst>
-                <a:tab pos="0" algn="l"/>
-              </a:tabLst>
-              <a:defRPr lang="en-US" sz="4000" b="1" u="none" strike="noStrike" cap="all">
+            <a:lvl1pPr algn="l" defTabSz="457200">
+              <a:lnSpc>
+                <a:spcPct val="100000"/>
+              </a:lnSpc>
+              <a:spcBef>
+                <a:spcPts val="641"/>
+              </a:spcBef>
+              <a:buClr>
+                <a:srgbClr val="000000"/>
+              </a:buClr>
+              <a:buFont typeface="Arial"/>
+              <a:buChar char="•"/>
+              <a:defRPr lang="en-US" sz="3200" b="0" u="none" strike="noStrike">
                 <a:solidFill>
                   <a:schemeClr val="dk1"/>
                 </a:solidFill>
@@ -2093,73 +1825,117 @@
                 <a:latin typeface="Calibri"/>
               </a:defRPr>
             </a:lvl1pPr>
+            <a:lvl2pPr lvl="1" algn="l" defTabSz="457200">
+              <a:lnSpc>
+                <a:spcPct val="100000"/>
+              </a:lnSpc>
+              <a:spcBef>
+                <a:spcPts val="561"/>
+              </a:spcBef>
+              <a:buClr>
+                <a:srgbClr val="000000"/>
+              </a:buClr>
+              <a:buFont typeface="Arial"/>
+              <a:buChar char="–"/>
+              <a:defRPr lang="en-US" sz="2800" b="0" u="none" strike="noStrike">
+                <a:solidFill>
+                  <a:schemeClr val="dk1"/>
+                </a:solidFill>
+                <a:effectLst/>
+                <a:uFillTx/>
+                <a:latin typeface="Calibri"/>
+              </a:defRPr>
+            </a:lvl2pPr>
+            <a:lvl3pPr lvl="2" algn="l" defTabSz="457200">
+              <a:lnSpc>
+                <a:spcPct val="100000"/>
+              </a:lnSpc>
+              <a:spcBef>
+                <a:spcPts val="479"/>
+              </a:spcBef>
+              <a:buClr>
+                <a:srgbClr val="000000"/>
+              </a:buClr>
+              <a:buFont typeface="Arial"/>
+              <a:buChar char="•"/>
+              <a:defRPr lang="en-US" sz="2400" b="0" u="none" strike="noStrike">
+                <a:solidFill>
+                  <a:schemeClr val="dk1"/>
+                </a:solidFill>
+                <a:effectLst/>
+                <a:uFillTx/>
+                <a:latin typeface="Calibri"/>
+              </a:defRPr>
+            </a:lvl3pPr>
+            <a:lvl4pPr lvl="3" algn="l" defTabSz="457200">
+              <a:lnSpc>
+                <a:spcPct val="100000"/>
+              </a:lnSpc>
+              <a:spcBef>
+                <a:spcPts val="400"/>
+              </a:spcBef>
+              <a:buClr>
+                <a:srgbClr val="000000"/>
+              </a:buClr>
+              <a:buFont typeface="Arial"/>
+              <a:buChar char="–"/>
+              <a:defRPr lang="en-US" sz="2000" b="0" u="none" strike="noStrike">
+                <a:solidFill>
+                  <a:schemeClr val="dk1"/>
+                </a:solidFill>
+                <a:effectLst/>
+                <a:uFillTx/>
+                <a:latin typeface="Calibri"/>
+              </a:defRPr>
+            </a:lvl4pPr>
+            <a:lvl5pPr lvl="4" algn="l" defTabSz="457200">
+              <a:lnSpc>
+                <a:spcPct val="100000"/>
+              </a:lnSpc>
+              <a:spcBef>
+                <a:spcPts val="400"/>
+              </a:spcBef>
+              <a:buClr>
+                <a:srgbClr val="000000"/>
+              </a:buClr>
+              <a:buFont typeface="Arial"/>
+              <a:buChar char="»"/>
+              <a:defRPr lang="en-US" sz="2000" b="0" u="none" strike="noStrike">
+                <a:solidFill>
+                  <a:schemeClr val="dk1"/>
+                </a:solidFill>
+                <a:effectLst/>
+                <a:uFillTx/>
+                <a:latin typeface="Calibri"/>
+              </a:defRPr>
+            </a:lvl5pPr>
           </a:lstStyle>
           <a:p>
-            <a:pPr indent="0" algn="l" defTabSz="457200">
-              <a:lnSpc>
-                <a:spcPct val="100000"/>
-              </a:lnSpc>
-              <a:buNone/>
-              <a:tabLst>
-                <a:tab pos="0" algn="l"/>
-              </a:tabLst>
-            </a:pPr>
-            <a:r>
-              <a:rPr lang="en-US" sz="4000" b="1" u="none" strike="noStrike" cap="all">
-                <a:solidFill>
-                  <a:schemeClr val="dk1"/>
-                </a:solidFill>
-                <a:effectLst/>
-                <a:uFillTx/>
-                <a:latin typeface="Calibri"/>
-              </a:rPr>
-              <a:t>Click </a:t>
-            </a:r>
-            <a:r>
-              <a:rPr lang="en-US" sz="4000" b="1" u="none" strike="noStrike" cap="all">
-                <a:solidFill>
-                  <a:schemeClr val="dk1"/>
-                </a:solidFill>
-                <a:effectLst/>
-                <a:uFillTx/>
-                <a:latin typeface="Calibri"/>
-              </a:rPr>
-              <a:t>to edit </a:t>
-            </a:r>
-            <a:r>
-              <a:rPr lang="en-US" sz="4000" b="1" u="none" strike="noStrike" cap="all">
-                <a:solidFill>
-                  <a:schemeClr val="dk1"/>
-                </a:solidFill>
-                <a:effectLst/>
-                <a:uFillTx/>
-                <a:latin typeface="Calibri"/>
-              </a:rPr>
-              <a:t>Master </a:t>
-            </a:r>
-            <a:r>
-              <a:rPr lang="en-US" sz="4000" b="1" u="none" strike="noStrike" cap="all">
-                <a:solidFill>
-                  <a:schemeClr val="dk1"/>
-                </a:solidFill>
-                <a:effectLst/>
-                <a:uFillTx/>
-                <a:latin typeface="Calibri"/>
-              </a:rPr>
-              <a:t>title </a:t>
-            </a:r>
-            <a:r>
-              <a:rPr lang="en-US" sz="4000" b="1" u="none" strike="noStrike" cap="all">
-                <a:solidFill>
-                  <a:schemeClr val="dk1"/>
-                </a:solidFill>
-                <a:effectLst/>
-                <a:uFillTx/>
-                <a:latin typeface="Calibri"/>
-              </a:rPr>
-              <a:t>style</a:t>
-            </a:r>
-            <a:endParaRPr lang="en-US" sz="4000" b="1" u="none" strike="noStrike" cap="all">
+            <a:pPr marL="343080" indent="-343080" algn="l" defTabSz="457200">
+              <a:lnSpc>
+                <a:spcPct val="100000"/>
+              </a:lnSpc>
+              <a:spcBef>
+                <a:spcPts val="641"/>
+              </a:spcBef>
+              <a:buClr>
+                <a:srgbClr val="000000"/>
+              </a:buClr>
+              <a:buFont typeface="Arial"/>
+              <a:buChar char="•"/>
+            </a:pPr>
+            <a:r>
+              <a:rPr lang="en-US" sz="3200" b="0" u="none" strike="noStrike">
+                <a:solidFill>
+                  <a:schemeClr val="dk1"/>
+                </a:solidFill>
+                <a:effectLst/>
+                <a:uFillTx/>
+                <a:latin typeface="Calibri"/>
+              </a:rPr>
+              <a:t>Click to edit Master text styles</a:t>
+            </a:r>
+            <a:endParaRPr lang="en-US" sz="3200" b="0" u="none" strike="noStrike">
               <a:solidFill>
                 <a:schemeClr val="dk1"/>
               </a:solidFill>
@@ -2168,90 +1944,136 @@
               <a:latin typeface="Calibri"/>
             </a:endParaRPr>
           </a:p>
-        </p:txBody>
-      </p:sp>
-      <p:sp>
-        <p:nvSpPr>
-          <p:cNvPr id="8" name="PlaceHolder 2"/>
-          <p:cNvSpPr>
-            <a:spLocks noGrp="1"/>
-          </p:cNvSpPr>
-          <p:nvPr>
-            <p:ph type="body"/>
-          </p:nvPr>
-        </p:nvSpPr>
-        <p:spPr>
-          <a:xfrm>
-            <a:off x="722160" y="2906640"/>
-            <a:ext cx="7768440" cy="1496160"/>
-          </a:xfrm>
-          <a:prstGeom prst="rect">
-            <a:avLst/>
-          </a:prstGeom>
-          <a:noFill/>
-          <a:ln w="0">
-            <a:noFill/>
-          </a:ln>
-        </p:spPr>
-        <p:txBody>
-          <a:bodyPr lIns="91440" tIns="45720" rIns="91440" bIns="45720" anchor="b">
-            <a:noAutofit/>
-          </a:bodyPr>
-          <a:lstStyle>
-            <a:lvl1pPr indent="0" algn="l" defTabSz="457200">
+          <a:p>
+            <a:pPr marL="743040" lvl="1" indent="-285840" algn="l" defTabSz="457200">
+              <a:lnSpc>
+                <a:spcPct val="100000"/>
+              </a:lnSpc>
+              <a:spcBef>
+                <a:spcPts val="561"/>
+              </a:spcBef>
+              <a:buClr>
+                <a:srgbClr val="000000"/>
+              </a:buClr>
+              <a:buFont typeface="Arial"/>
+              <a:buChar char="–"/>
+            </a:pPr>
+            <a:r>
+              <a:rPr lang="en-US" sz="2800" b="0" u="none" strike="noStrike">
+                <a:solidFill>
+                  <a:schemeClr val="dk1"/>
+                </a:solidFill>
+                <a:effectLst/>
+                <a:uFillTx/>
+                <a:latin typeface="Calibri"/>
+              </a:rPr>
+              <a:t>Second level</a:t>
+            </a:r>
+            <a:endParaRPr lang="en-US" sz="2800" b="0" u="none" strike="noStrike">
+              <a:solidFill>
+                <a:schemeClr val="dk1"/>
+              </a:solidFill>
+              <a:effectLst/>
+              <a:uFillTx/>
+              <a:latin typeface="Calibri"/>
+            </a:endParaRPr>
+          </a:p>
+          <a:p>
+            <a:pPr marL="1143000" lvl="2" indent="-228600" algn="l" defTabSz="457200">
+              <a:lnSpc>
+                <a:spcPct val="100000"/>
+              </a:lnSpc>
+              <a:spcBef>
+                <a:spcPts val="479"/>
+              </a:spcBef>
+              <a:buClr>
+                <a:srgbClr val="000000"/>
+              </a:buClr>
+              <a:buFont typeface="Arial"/>
+              <a:buChar char="•"/>
+            </a:pPr>
+            <a:r>
+              <a:rPr lang="en-US" sz="2400" b="0" u="none" strike="noStrike">
+                <a:solidFill>
+                  <a:schemeClr val="dk1"/>
+                </a:solidFill>
+                <a:effectLst/>
+                <a:uFillTx/>
+                <a:latin typeface="Calibri"/>
+              </a:rPr>
+              <a:t>Third level</a:t>
+            </a:r>
+            <a:endParaRPr lang="en-US" sz="2400" b="0" u="none" strike="noStrike">
+              <a:solidFill>
+                <a:schemeClr val="dk1"/>
+              </a:solidFill>
+              <a:effectLst/>
+              <a:uFillTx/>
+              <a:latin typeface="Calibri"/>
+            </a:endParaRPr>
+          </a:p>
+          <a:p>
+            <a:pPr marL="1600200" lvl="3" indent="-228600" algn="l" defTabSz="457200">
               <a:lnSpc>
                 <a:spcPct val="100000"/>
               </a:lnSpc>
               <a:spcBef>
                 <a:spcPts val="400"/>
               </a:spcBef>
-              <a:buNone/>
-              <a:tabLst>
-                <a:tab pos="0" algn="l"/>
-              </a:tabLst>
-              <a:defRPr lang="en-US" sz="2000" b="0" u="none" strike="noStrike">
-                <a:solidFill>
-                  <a:schemeClr val="dk1">
-                    <a:tint val="75000"/>
-                  </a:schemeClr>
-                </a:solidFill>
-                <a:effectLst/>
-                <a:uFillTx/>
-                <a:latin typeface="Calibri"/>
-              </a:defRPr>
-            </a:lvl1pPr>
-          </a:lstStyle>
-          <a:p>
-            <a:pPr indent="0" algn="l" defTabSz="457200">
+              <a:buClr>
+                <a:srgbClr val="000000"/>
+              </a:buClr>
+              <a:buFont typeface="Arial"/>
+              <a:buChar char="–"/>
+            </a:pPr>
+            <a:r>
+              <a:rPr lang="en-US" sz="2000" b="0" u="none" strike="noStrike">
+                <a:solidFill>
+                  <a:schemeClr val="dk1"/>
+                </a:solidFill>
+                <a:effectLst/>
+                <a:uFillTx/>
+                <a:latin typeface="Calibri"/>
+              </a:rPr>
+              <a:t>Fourth level</a:t>
+            </a:r>
+            <a:endParaRPr lang="en-US" sz="2000" b="0" u="none" strike="noStrike">
+              <a:solidFill>
+                <a:schemeClr val="dk1"/>
+              </a:solidFill>
+              <a:effectLst/>
+              <a:uFillTx/>
+              <a:latin typeface="Calibri"/>
+            </a:endParaRPr>
+          </a:p>
+          <a:p>
+            <a:pPr marL="2057400" lvl="4" indent="-228600" algn="l" defTabSz="457200">
               <a:lnSpc>
                 <a:spcPct val="100000"/>
               </a:lnSpc>
               <a:spcBef>
                 <a:spcPts val="400"/>
               </a:spcBef>
-              <a:buNone/>
-              <a:tabLst>
-                <a:tab pos="0" algn="l"/>
-              </a:tabLst>
+              <a:buClr>
+                <a:srgbClr val="000000"/>
+              </a:buClr>
+              <a:buFont typeface="Arial"/>
+              <a:buChar char="»"/>
             </a:pPr>
             <a:r>
               <a:rPr lang="en-US" sz="2000" b="0" u="none" strike="noStrike">
                 <a:solidFill>
-                  <a:schemeClr val="dk1">
-                    <a:tint val="75000"/>
-                  </a:schemeClr>
-                </a:solidFill>
-                <a:effectLst/>
-                <a:uFillTx/>
-                <a:latin typeface="Calibri"/>
-              </a:rPr>
-              <a:t>Click to edit Master text styles</a:t>
+                  <a:schemeClr val="dk1"/>
+                </a:solidFill>
+                <a:effectLst/>
+                <a:uFillTx/>
+                <a:latin typeface="Calibri"/>
+              </a:rPr>
+              <a:t>Fifth level</a:t>
             </a:r>
             <a:endParaRPr lang="en-US" sz="2000" b="0" u="none" strike="noStrike">
               <a:solidFill>
-                <a:schemeClr val="dk1">
-                  <a:tint val="75000"/>
-                </a:schemeClr>
+                <a:schemeClr val="dk1"/>
               </a:solidFill>
               <a:effectLst/>
               <a:uFillTx/>
@@ -2273,7 +2095,7 @@
         <p:spPr>
           <a:xfrm>
             <a:off x="457200" y="6356520"/>
-            <a:ext cx="2129760" cy="361080"/>
+            <a:ext cx="2128320" cy="359640"/>
           </a:xfrm>
           <a:prstGeom prst="rect">
             <a:avLst/>
@@ -2329,7 +2151,7 @@
                 <a:uFillTx/>
                 <a:latin typeface="Calibri"/>
               </a:rPr>
-              <a:t>&lt;date/time&gt;</a:t>
+              <a:t> </a:t>
             </a:r>
             <a:endParaRPr lang="en-US" sz="1200" b="0" u="none" strike="noStrike">
               <a:solidFill>
@@ -2355,7 +2177,7 @@
         <p:spPr>
           <a:xfrm>
             <a:off x="3124080" y="6356520"/>
-            <a:ext cx="2891520" cy="361080"/>
+            <a:ext cx="2890080" cy="359640"/>
           </a:xfrm>
           <a:prstGeom prst="rect">
             <a:avLst/>
@@ -2407,7 +2229,7 @@
                 <a:uFillTx/>
                 <a:latin typeface="Times New Roman"/>
               </a:rPr>
-              <a:t>&lt;footer&gt;</a:t>
+              <a:t> </a:t>
             </a:r>
             <a:endParaRPr lang="en-US" sz="1400" b="0" u="none" strike="noStrike">
               <a:solidFill>
@@ -2433,7 +2255,7 @@
         <p:spPr>
           <a:xfrm>
             <a:off x="6553080" y="6356520"/>
-            <a:ext cx="2129760" cy="361080"/>
+            <a:ext cx="2128320" cy="359640"/>
           </a:xfrm>
           <a:prstGeom prst="rect">
             <a:avLst/>
@@ -2478,7 +2300,7 @@
                 <a:tab pos="0" algn="l"/>
               </a:tabLst>
             </a:pPr>
-            <a:fld id="{900891BC-EF9C-43E8-A2BF-A208C457A536}" type="slidenum">
+            <a:fld id="{792DF33A-3823-4B11-9E3A-EEE919AD2E82}" type="slidenum">
               <a:rPr lang="en-US" sz="1200" b="0" u="none" strike="noStrike">
                 <a:solidFill>
                   <a:schemeClr val="dk1">
@@ -2489,7 +2311,7 @@
                 <a:uFillTx/>
                 <a:latin typeface="Calibri"/>
               </a:rPr>
-              <a:t>&lt;number&gt;</a:t>
+              <a:t>3</a:t>
             </a:fld>
             <a:endParaRPr lang="en-US" sz="1200" b="0" u="none" strike="noStrike">
               <a:solidFill>
@@ -2508,8 +2330,8 @@
 </file>
 
 <file path=ppt/slideLayouts/slideLayout3.xml><?xml version="1.0" encoding="utf-8"?>
-<p:sldLayout xmlns:a="http://schemas.openxmlformats.org/drawingml/2006/main" xmlns:p="http://schemas.openxmlformats.org/presentationml/2006/main" xmlns:r="http://schemas.openxmlformats.org/officeDocument/2006/relationships" xmlns:p14="http://schemas.microsoft.com/office/powerpoint/2010/main" xmlns:p15="http://schemas.microsoft.com/office/powerpoint/2012/main" xmlns:mc="http://schemas.openxmlformats.org/markup-compatibility/2006" type="twoObj" preserve="1">
-  <p:cSld name="Two Content">
+<p:sldLayout xmlns:a="http://schemas.openxmlformats.org/drawingml/2006/main" xmlns:p="http://schemas.openxmlformats.org/presentationml/2006/main" xmlns:r="http://schemas.openxmlformats.org/officeDocument/2006/relationships" xmlns:p14="http://schemas.microsoft.com/office/powerpoint/2010/main" xmlns:p15="http://schemas.microsoft.com/office/powerpoint/2012/main" xmlns:mc="http://schemas.openxmlformats.org/markup-compatibility/2006" type="blank" preserve="1">
+  <p:cSld name="Section Header">
     <p:bg>
       <p:bgPr>
         <a:solidFill>
@@ -2543,8 +2365,447 @@
         </p:nvSpPr>
         <p:spPr>
           <a:xfrm>
+            <a:off x="722160" y="4406760"/>
+            <a:ext cx="7767000" cy="1356840"/>
+          </a:xfrm>
+          <a:prstGeom prst="rect">
+            <a:avLst/>
+          </a:prstGeom>
+          <a:noFill/>
+          <a:ln w="0">
+            <a:noFill/>
+          </a:ln>
+        </p:spPr>
+        <p:txBody>
+          <a:bodyPr lIns="91440" tIns="45720" rIns="91440" bIns="45720" anchor="t">
+            <a:noAutofit/>
+          </a:bodyPr>
+          <a:lstStyle>
+            <a:lvl1pPr indent="0" algn="l" defTabSz="457200">
+              <a:lnSpc>
+                <a:spcPct val="100000"/>
+              </a:lnSpc>
+              <a:buNone/>
+              <a:tabLst>
+                <a:tab pos="0" algn="l"/>
+              </a:tabLst>
+              <a:defRPr lang="en-US" sz="4000" b="1" u="none" strike="noStrike" cap="all">
+                <a:solidFill>
+                  <a:schemeClr val="dk1"/>
+                </a:solidFill>
+                <a:effectLst/>
+                <a:uFillTx/>
+                <a:latin typeface="Calibri"/>
+              </a:defRPr>
+            </a:lvl1pPr>
+          </a:lstStyle>
+          <a:p>
+            <a:pPr indent="0" algn="l" defTabSz="457200">
+              <a:lnSpc>
+                <a:spcPct val="100000"/>
+              </a:lnSpc>
+              <a:buNone/>
+              <a:tabLst>
+                <a:tab pos="0" algn="l"/>
+              </a:tabLst>
+            </a:pPr>
+            <a:r>
+              <a:rPr lang="en-US" sz="4000" b="1" u="none" strike="noStrike" cap="all">
+                <a:solidFill>
+                  <a:schemeClr val="dk1"/>
+                </a:solidFill>
+                <a:effectLst/>
+                <a:uFillTx/>
+                <a:latin typeface="Calibri"/>
+              </a:rPr>
+              <a:t>Click to edit Master title style</a:t>
+            </a:r>
+            <a:endParaRPr lang="en-US" sz="4000" b="1" u="none" strike="noStrike" cap="all">
+              <a:solidFill>
+                <a:schemeClr val="dk1"/>
+              </a:solidFill>
+              <a:effectLst/>
+              <a:uFillTx/>
+              <a:latin typeface="Calibri"/>
+            </a:endParaRPr>
+          </a:p>
+        </p:txBody>
+      </p:sp>
+      <p:sp>
+        <p:nvSpPr>
+          <p:cNvPr id="13" name="PlaceHolder 2"/>
+          <p:cNvSpPr>
+            <a:spLocks noGrp="1"/>
+          </p:cNvSpPr>
+          <p:nvPr>
+            <p:ph type="body"/>
+          </p:nvPr>
+        </p:nvSpPr>
+        <p:spPr>
+          <a:xfrm>
+            <a:off x="722160" y="2906640"/>
+            <a:ext cx="7767000" cy="1494720"/>
+          </a:xfrm>
+          <a:prstGeom prst="rect">
+            <a:avLst/>
+          </a:prstGeom>
+          <a:noFill/>
+          <a:ln w="0">
+            <a:noFill/>
+          </a:ln>
+        </p:spPr>
+        <p:txBody>
+          <a:bodyPr lIns="91440" tIns="45720" rIns="91440" bIns="45720" anchor="b">
+            <a:noAutofit/>
+          </a:bodyPr>
+          <a:lstStyle>
+            <a:lvl1pPr indent="0" algn="l" defTabSz="457200">
+              <a:lnSpc>
+                <a:spcPct val="100000"/>
+              </a:lnSpc>
+              <a:spcBef>
+                <a:spcPts val="400"/>
+              </a:spcBef>
+              <a:buNone/>
+              <a:tabLst>
+                <a:tab pos="0" algn="l"/>
+              </a:tabLst>
+              <a:defRPr lang="en-US" sz="2000" b="0" u="none" strike="noStrike">
+                <a:solidFill>
+                  <a:schemeClr val="dk1">
+                    <a:tint val="75000"/>
+                  </a:schemeClr>
+                </a:solidFill>
+                <a:effectLst/>
+                <a:uFillTx/>
+                <a:latin typeface="Calibri"/>
+              </a:defRPr>
+            </a:lvl1pPr>
+          </a:lstStyle>
+          <a:p>
+            <a:pPr indent="0" algn="l" defTabSz="457200">
+              <a:lnSpc>
+                <a:spcPct val="100000"/>
+              </a:lnSpc>
+              <a:spcBef>
+                <a:spcPts val="400"/>
+              </a:spcBef>
+              <a:buNone/>
+              <a:tabLst>
+                <a:tab pos="0" algn="l"/>
+              </a:tabLst>
+            </a:pPr>
+            <a:r>
+              <a:rPr lang="en-US" sz="2000" b="0" u="none" strike="noStrike">
+                <a:solidFill>
+                  <a:schemeClr val="dk1">
+                    <a:tint val="75000"/>
+                  </a:schemeClr>
+                </a:solidFill>
+                <a:effectLst/>
+                <a:uFillTx/>
+                <a:latin typeface="Calibri"/>
+              </a:rPr>
+              <a:t>Click to edit Master text styles</a:t>
+            </a:r>
+            <a:endParaRPr lang="en-US" sz="2000" b="0" u="none" strike="noStrike">
+              <a:solidFill>
+                <a:schemeClr val="dk1">
+                  <a:tint val="75000"/>
+                </a:schemeClr>
+              </a:solidFill>
+              <a:effectLst/>
+              <a:uFillTx/>
+              <a:latin typeface="Calibri"/>
+            </a:endParaRPr>
+          </a:p>
+        </p:txBody>
+      </p:sp>
+      <p:sp>
+        <p:nvSpPr>
+          <p:cNvPr id="14" name="PlaceHolder 3"/>
+          <p:cNvSpPr>
+            <a:spLocks noGrp="1"/>
+          </p:cNvSpPr>
+          <p:nvPr>
+            <p:ph type="dt" idx="7"/>
+          </p:nvPr>
+        </p:nvSpPr>
+        <p:spPr>
+          <a:xfrm>
+            <a:off x="457200" y="6356520"/>
+            <a:ext cx="2128320" cy="359640"/>
+          </a:xfrm>
+          <a:prstGeom prst="rect">
+            <a:avLst/>
+          </a:prstGeom>
+          <a:noFill/>
+          <a:ln w="0">
+            <a:noFill/>
+          </a:ln>
+        </p:spPr>
+        <p:txBody>
+          <a:bodyPr lIns="91440" tIns="45720" rIns="91440" bIns="45720" anchor="ctr">
+            <a:noAutofit/>
+          </a:bodyPr>
+          <a:lstStyle>
+            <a:lvl1pPr indent="0" algn="l" defTabSz="457200">
+              <a:lnSpc>
+                <a:spcPct val="100000"/>
+              </a:lnSpc>
+              <a:buNone/>
+              <a:tabLst>
+                <a:tab pos="0" algn="l"/>
+              </a:tabLst>
+              <a:defRPr lang="en-US" sz="1200" b="0" u="none" strike="noStrike">
+                <a:solidFill>
+                  <a:schemeClr val="dk1">
+                    <a:tint val="75000"/>
+                  </a:schemeClr>
+                </a:solidFill>
+                <a:effectLst/>
+                <a:uFillTx/>
+                <a:latin typeface="Calibri"/>
+              </a:defRPr>
+            </a:lvl1pPr>
+          </a:lstStyle>
+          <a:p>
+            <a:pPr indent="0" algn="l" defTabSz="457200">
+              <a:lnSpc>
+                <a:spcPct val="100000"/>
+              </a:lnSpc>
+              <a:buNone/>
+              <a:tabLst>
+                <a:tab pos="0" algn="l"/>
+              </a:tabLst>
+            </a:pPr>
+            <a:r>
+              <a:rPr lang="en-US" sz="1200" b="0" u="none" strike="noStrike">
+                <a:solidFill>
+                  <a:schemeClr val="dk1">
+                    <a:tint val="75000"/>
+                  </a:schemeClr>
+                </a:solidFill>
+                <a:effectLst/>
+                <a:uFillTx/>
+                <a:latin typeface="Calibri"/>
+              </a:rPr>
+              <a:t> </a:t>
+            </a:r>
+            <a:endParaRPr lang="en-US" sz="1200" b="0" u="none" strike="noStrike">
+              <a:solidFill>
+                <a:srgbClr val="000000"/>
+              </a:solidFill>
+              <a:effectLst/>
+              <a:uFillTx/>
+              <a:latin typeface="Times New Roman"/>
+            </a:endParaRPr>
+          </a:p>
+        </p:txBody>
+      </p:sp>
+      <p:sp>
+        <p:nvSpPr>
+          <p:cNvPr id="15" name="PlaceHolder 4"/>
+          <p:cNvSpPr>
+            <a:spLocks noGrp="1"/>
+          </p:cNvSpPr>
+          <p:nvPr>
+            <p:ph type="ftr" idx="8"/>
+          </p:nvPr>
+        </p:nvSpPr>
+        <p:spPr>
+          <a:xfrm>
+            <a:off x="3124080" y="6356520"/>
+            <a:ext cx="2890080" cy="359640"/>
+          </a:xfrm>
+          <a:prstGeom prst="rect">
+            <a:avLst/>
+          </a:prstGeom>
+          <a:noFill/>
+          <a:ln w="0">
+            <a:noFill/>
+          </a:ln>
+        </p:spPr>
+        <p:txBody>
+          <a:bodyPr lIns="91440" tIns="45720" rIns="91440" bIns="45720" anchor="ctr">
+            <a:noAutofit/>
+          </a:bodyPr>
+          <a:lstStyle>
+            <a:lvl1pPr indent="0" algn="ctr">
+              <a:lnSpc>
+                <a:spcPct val="100000"/>
+              </a:lnSpc>
+              <a:buNone/>
+              <a:tabLst>
+                <a:tab pos="0" algn="l"/>
+              </a:tabLst>
+              <a:defRPr lang="en-US" sz="1400" b="0" u="none" strike="noStrike">
+                <a:solidFill>
+                  <a:srgbClr val="000000"/>
+                </a:solidFill>
+                <a:effectLst/>
+                <a:uFillTx/>
+                <a:latin typeface="Times New Roman"/>
+              </a:defRPr>
+            </a:lvl1pPr>
+          </a:lstStyle>
+          <a:p>
+            <a:pPr indent="0" algn="ctr">
+              <a:lnSpc>
+                <a:spcPct val="100000"/>
+              </a:lnSpc>
+              <a:buNone/>
+              <a:tabLst>
+                <a:tab pos="0" algn="l"/>
+              </a:tabLst>
+            </a:pPr>
+            <a:r>
+              <a:rPr lang="en-US" sz="1400" b="0" u="none" strike="noStrike">
+                <a:solidFill>
+                  <a:srgbClr val="000000"/>
+                </a:solidFill>
+                <a:effectLst/>
+                <a:uFillTx/>
+                <a:latin typeface="Times New Roman"/>
+              </a:rPr>
+              <a:t> </a:t>
+            </a:r>
+            <a:endParaRPr lang="en-US" sz="1400" b="0" u="none" strike="noStrike">
+              <a:solidFill>
+                <a:srgbClr val="000000"/>
+              </a:solidFill>
+              <a:effectLst/>
+              <a:uFillTx/>
+              <a:latin typeface="Times New Roman"/>
+            </a:endParaRPr>
+          </a:p>
+        </p:txBody>
+      </p:sp>
+      <p:sp>
+        <p:nvSpPr>
+          <p:cNvPr id="16" name="PlaceHolder 5"/>
+          <p:cNvSpPr>
+            <a:spLocks noGrp="1"/>
+          </p:cNvSpPr>
+          <p:nvPr>
+            <p:ph type="sldNum" idx="9"/>
+          </p:nvPr>
+        </p:nvSpPr>
+        <p:spPr>
+          <a:xfrm>
+            <a:off x="6553080" y="6356520"/>
+            <a:ext cx="2128320" cy="359640"/>
+          </a:xfrm>
+          <a:prstGeom prst="rect">
+            <a:avLst/>
+          </a:prstGeom>
+          <a:noFill/>
+          <a:ln w="0">
+            <a:noFill/>
+          </a:ln>
+        </p:spPr>
+        <p:txBody>
+          <a:bodyPr lIns="91440" tIns="45720" rIns="91440" bIns="45720" anchor="ctr">
+            <a:noAutofit/>
+          </a:bodyPr>
+          <a:lstStyle>
+            <a:lvl1pPr indent="0" algn="r" defTabSz="457200">
+              <a:lnSpc>
+                <a:spcPct val="100000"/>
+              </a:lnSpc>
+              <a:buNone/>
+              <a:tabLst>
+                <a:tab pos="0" algn="l"/>
+              </a:tabLst>
+              <a:defRPr lang="en-US" sz="1200" b="0" u="none" strike="noStrike">
+                <a:solidFill>
+                  <a:schemeClr val="dk1">
+                    <a:tint val="75000"/>
+                  </a:schemeClr>
+                </a:solidFill>
+                <a:effectLst/>
+                <a:uFillTx/>
+                <a:latin typeface="Calibri"/>
+              </a:defRPr>
+            </a:lvl1pPr>
+          </a:lstStyle>
+          <a:p>
+            <a:pPr indent="0" algn="r" defTabSz="457200">
+              <a:lnSpc>
+                <a:spcPct val="100000"/>
+              </a:lnSpc>
+              <a:buNone/>
+              <a:tabLst>
+                <a:tab pos="0" algn="l"/>
+              </a:tabLst>
+            </a:pPr>
+            <a:fld id="{397EC591-D393-4417-8C05-D09815383D45}" type="slidenum">
+              <a:rPr lang="en-US" sz="1200" b="0" u="none" strike="noStrike">
+                <a:solidFill>
+                  <a:schemeClr val="dk1">
+                    <a:tint val="75000"/>
+                  </a:schemeClr>
+                </a:solidFill>
+                <a:effectLst/>
+                <a:uFillTx/>
+                <a:latin typeface="Calibri"/>
+              </a:rPr>
+              <a:t>3</a:t>
+            </a:fld>
+            <a:endParaRPr lang="en-US" sz="1200" b="0" u="none" strike="noStrike">
+              <a:solidFill>
+                <a:srgbClr val="000000"/>
+              </a:solidFill>
+              <a:effectLst/>
+              <a:uFillTx/>
+              <a:latin typeface="Times New Roman"/>
+            </a:endParaRPr>
+          </a:p>
+        </p:txBody>
+      </p:sp>
+    </p:spTree>
+  </p:cSld>
+</p:sldLayout>
+</file>
+
+<file path=ppt/slideLayouts/slideLayout4.xml><?xml version="1.0" encoding="utf-8"?>
+<p:sldLayout xmlns:a="http://schemas.openxmlformats.org/drawingml/2006/main" xmlns:p="http://schemas.openxmlformats.org/presentationml/2006/main" xmlns:r="http://schemas.openxmlformats.org/officeDocument/2006/relationships" xmlns:p14="http://schemas.microsoft.com/office/powerpoint/2010/main" xmlns:p15="http://schemas.microsoft.com/office/powerpoint/2012/main" xmlns:mc="http://schemas.openxmlformats.org/markup-compatibility/2006" type="twoObj" preserve="1">
+  <p:cSld name="Two Content">
+    <p:bg>
+      <p:bgPr>
+        <a:solidFill>
+          <a:srgbClr val="FFFFFF"/>
+        </a:solidFill>
+      </p:bgPr>
+    </p:bg>
+    <p:spTree>
+      <p:nvGrpSpPr>
+        <p:cNvPr id="1" name=""/>
+        <p:cNvGrpSpPr/>
+        <p:nvPr/>
+      </p:nvGrpSpPr>
+      <p:grpSpPr>
+        <a:xfrm>
+          <a:off x="0" y="0"/>
+          <a:ext cx="0" cy="0"/>
+          <a:chOff x="0" y="0"/>
+          <a:chExt cx="0" cy="0"/>
+        </a:xfrm>
+      </p:grpSpPr>
+      <p:sp>
+        <p:nvSpPr>
+          <p:cNvPr id="17" name="PlaceHolder 1"/>
+          <p:cNvSpPr>
+            <a:spLocks noGrp="1"/>
+          </p:cNvSpPr>
+          <p:nvPr>
+            <p:ph type="title"/>
+          </p:nvPr>
+        </p:nvSpPr>
+        <p:spPr>
+          <a:xfrm>
             <a:off x="457200" y="274680"/>
-            <a:ext cx="8225640" cy="1139040"/>
+            <a:ext cx="8224200" cy="1137600"/>
           </a:xfrm>
           <a:prstGeom prst="rect">
             <a:avLst/>
@@ -2611,7 +2872,7 @@
       </p:sp>
       <p:sp>
         <p:nvSpPr>
-          <p:cNvPr id="13" name="PlaceHolder 2"/>
+          <p:cNvPr id="18" name="PlaceHolder 2"/>
           <p:cNvSpPr>
             <a:spLocks noGrp="1"/>
           </p:cNvSpPr>
@@ -2622,7 +2883,7 @@
         <p:spPr>
           <a:xfrm>
             <a:off x="457200" y="1600200"/>
-            <a:ext cx="4034520" cy="4521960"/>
+            <a:ext cx="4033080" cy="4520520"/>
           </a:xfrm>
           <a:prstGeom prst="rect">
             <a:avLst/>
@@ -2917,7 +3178,7 @@
       </p:sp>
       <p:sp>
         <p:nvSpPr>
-          <p:cNvPr id="14" name="PlaceHolder 3"/>
+          <p:cNvPr id="19" name="PlaceHolder 3"/>
           <p:cNvSpPr>
             <a:spLocks noGrp="1"/>
           </p:cNvSpPr>
@@ -2928,7 +3189,7 @@
         <p:spPr>
           <a:xfrm>
             <a:off x="4648320" y="1600200"/>
-            <a:ext cx="4034520" cy="4521960"/>
+            <a:ext cx="4033080" cy="4520520"/>
           </a:xfrm>
           <a:prstGeom prst="rect">
             <a:avLst/>
@@ -3223,18 +3484,18 @@
       </p:sp>
       <p:sp>
         <p:nvSpPr>
-          <p:cNvPr id="15" name="PlaceHolder 4"/>
+          <p:cNvPr id="20" name="PlaceHolder 4"/>
           <p:cNvSpPr>
             <a:spLocks noGrp="1"/>
           </p:cNvSpPr>
           <p:nvPr>
-            <p:ph type="dt" idx="7"/>
+            <p:ph type="dt" idx="10"/>
           </p:nvPr>
         </p:nvSpPr>
         <p:spPr>
           <a:xfrm>
             <a:off x="457200" y="6356520"/>
-            <a:ext cx="2129760" cy="361080"/>
+            <a:ext cx="2128320" cy="359640"/>
           </a:xfrm>
           <a:prstGeom prst="rect">
             <a:avLst/>
@@ -3290,7 +3551,7 @@
                 <a:uFillTx/>
                 <a:latin typeface="Calibri"/>
               </a:rPr>
-              <a:t>&lt;date/time&gt;</a:t>
+              <a:t> </a:t>
             </a:r>
             <a:endParaRPr lang="en-US" sz="1200" b="0" u="none" strike="noStrike">
               <a:solidFill>
@@ -3305,18 +3566,18 @@
       </p:sp>
       <p:sp>
         <p:nvSpPr>
-          <p:cNvPr id="16" name="PlaceHolder 5"/>
+          <p:cNvPr id="21" name="PlaceHolder 5"/>
           <p:cNvSpPr>
             <a:spLocks noGrp="1"/>
           </p:cNvSpPr>
           <p:nvPr>
-            <p:ph type="ftr" idx="8"/>
+            <p:ph type="ftr" idx="11"/>
           </p:nvPr>
         </p:nvSpPr>
         <p:spPr>
           <a:xfrm>
             <a:off x="3124080" y="6356520"/>
-            <a:ext cx="2891520" cy="361080"/>
+            <a:ext cx="2890080" cy="359640"/>
           </a:xfrm>
           <a:prstGeom prst="rect">
             <a:avLst/>
@@ -3368,7 +3629,7 @@
                 <a:uFillTx/>
                 <a:latin typeface="Times New Roman"/>
               </a:rPr>
-              <a:t>&lt;footer&gt;</a:t>
+              <a:t> </a:t>
             </a:r>
             <a:endParaRPr lang="en-US" sz="1400" b="0" u="none" strike="noStrike">
               <a:solidFill>
@@ -3383,18 +3644,18 @@
       </p:sp>
       <p:sp>
         <p:nvSpPr>
-          <p:cNvPr id="17" name="PlaceHolder 6"/>
+          <p:cNvPr id="22" name="PlaceHolder 6"/>
           <p:cNvSpPr>
             <a:spLocks noGrp="1"/>
           </p:cNvSpPr>
           <p:nvPr>
-            <p:ph type="sldNum" idx="9"/>
+            <p:ph type="sldNum" idx="12"/>
           </p:nvPr>
         </p:nvSpPr>
         <p:spPr>
           <a:xfrm>
             <a:off x="6553080" y="6356520"/>
-            <a:ext cx="2129760" cy="361080"/>
+            <a:ext cx="2128320" cy="359640"/>
           </a:xfrm>
           <a:prstGeom prst="rect">
             <a:avLst/>
@@ -3439,7 +3700,7 @@
                 <a:tab pos="0" algn="l"/>
               </a:tabLst>
             </a:pPr>
-            <a:fld id="{2CC28586-5417-4548-8520-295662D08B14}" type="slidenum">
+            <a:fld id="{166CD367-9AA1-49B6-9171-154745D36539}" type="slidenum">
               <a:rPr lang="en-US" sz="1200" b="0" u="none" strike="noStrike">
                 <a:solidFill>
                   <a:schemeClr val="dk1">
@@ -3450,7 +3711,7 @@
                 <a:uFillTx/>
                 <a:latin typeface="Calibri"/>
               </a:rPr>
-              <a:t>&lt;number&gt;</a:t>
+              <a:t>3</a:t>
             </a:fld>
             <a:endParaRPr lang="en-US" sz="1200" b="0" u="none" strike="noStrike">
               <a:solidFill>
@@ -3468,7 +3729,7 @@
 </p:sldLayout>
 </file>
 
-<file path=ppt/slideLayouts/slideLayout4.xml><?xml version="1.0" encoding="utf-8"?>
+<file path=ppt/slideLayouts/slideLayout5.xml><?xml version="1.0" encoding="utf-8"?>
 <p:sldLayout xmlns:a="http://schemas.openxmlformats.org/drawingml/2006/main" xmlns:p="http://schemas.openxmlformats.org/presentationml/2006/main" xmlns:r="http://schemas.openxmlformats.org/officeDocument/2006/relationships" xmlns:p14="http://schemas.microsoft.com/office/powerpoint/2010/main" xmlns:p15="http://schemas.microsoft.com/office/powerpoint/2012/main" xmlns:mc="http://schemas.openxmlformats.org/markup-compatibility/2006" type="blank" preserve="1">
   <p:cSld name="Comparison">
     <p:bg>
@@ -3494,7 +3755,7 @@
       </p:grpSpPr>
       <p:sp>
         <p:nvSpPr>
-          <p:cNvPr id="18" name="PlaceHolder 1"/>
+          <p:cNvPr id="23" name="PlaceHolder 1"/>
           <p:cNvSpPr>
             <a:spLocks noGrp="1"/>
           </p:cNvSpPr>
@@ -3505,7 +3766,7 @@
         <p:spPr>
           <a:xfrm>
             <a:off x="457200" y="274680"/>
-            <a:ext cx="8225640" cy="1139040"/>
+            <a:ext cx="8224200" cy="1137600"/>
           </a:xfrm>
           <a:prstGeom prst="rect">
             <a:avLst/>
@@ -3557,7 +3818,51 @@
                 <a:uFillTx/>
                 <a:latin typeface="Calibri"/>
               </a:rPr>
-              <a:t>Click to edit Master title style</a:t>
+              <a:t>Click to </a:t>
+            </a:r>
+            <a:r>
+              <a:rPr lang="en-US" sz="4400" b="0" u="none" strike="noStrike">
+                <a:solidFill>
+                  <a:schemeClr val="dk1"/>
+                </a:solidFill>
+                <a:effectLst/>
+                <a:uFillTx/>
+                <a:latin typeface="Calibri"/>
+              </a:rPr>
+              <a:t>edit </a:t>
+            </a:r>
+            <a:r>
+              <a:rPr lang="en-US" sz="4400" b="0" u="none" strike="noStrike">
+                <a:solidFill>
+                  <a:schemeClr val="dk1"/>
+                </a:solidFill>
+                <a:effectLst/>
+                <a:uFillTx/>
+                <a:latin typeface="Calibri"/>
+              </a:rPr>
+              <a:t>Master </a:t>
+            </a:r>
+            <a:r>
+              <a:rPr lang="en-US" sz="4400" b="0" u="none" strike="noStrike">
+                <a:solidFill>
+                  <a:schemeClr val="dk1"/>
+                </a:solidFill>
+                <a:effectLst/>
+                <a:uFillTx/>
+                <a:latin typeface="Calibri"/>
+              </a:rPr>
+              <a:t>title </a:t>
+            </a:r>
+            <a:r>
+              <a:rPr lang="en-US" sz="4400" b="0" u="none" strike="noStrike">
+                <a:solidFill>
+                  <a:schemeClr val="dk1"/>
+                </a:solidFill>
+                <a:effectLst/>
+                <a:uFillTx/>
+                <a:latin typeface="Calibri"/>
+              </a:rPr>
+              <a:t>style</a:t>
             </a:r>
             <a:endParaRPr lang="en-US" sz="4400" b="0" u="none" strike="noStrike">
               <a:solidFill>
@@ -3572,7 +3877,7 @@
       </p:sp>
       <p:sp>
         <p:nvSpPr>
-          <p:cNvPr id="19" name="PlaceHolder 2"/>
+          <p:cNvPr id="24" name="PlaceHolder 2"/>
           <p:cNvSpPr>
             <a:spLocks noGrp="1"/>
           </p:cNvSpPr>
@@ -3583,7 +3888,7 @@
         <p:spPr>
           <a:xfrm>
             <a:off x="457200" y="1535040"/>
-            <a:ext cx="4036320" cy="635760"/>
+            <a:ext cx="4034880" cy="634320"/>
           </a:xfrm>
           <a:prstGeom prst="rect">
             <a:avLst/>
@@ -3656,7 +3961,7 @@
       </p:sp>
       <p:sp>
         <p:nvSpPr>
-          <p:cNvPr id="20" name="PlaceHolder 3"/>
+          <p:cNvPr id="25" name="PlaceHolder 3"/>
           <p:cNvSpPr>
             <a:spLocks noGrp="1"/>
           </p:cNvSpPr>
@@ -3667,7 +3972,7 @@
         <p:spPr>
           <a:xfrm>
             <a:off x="457200" y="2174760"/>
-            <a:ext cx="4036320" cy="3947400"/>
+            <a:ext cx="4034880" cy="3945960"/>
           </a:xfrm>
           <a:prstGeom prst="rect">
             <a:avLst/>
@@ -3992,7 +4297,7 @@
       </p:sp>
       <p:sp>
         <p:nvSpPr>
-          <p:cNvPr id="21" name="PlaceHolder 4"/>
+          <p:cNvPr id="26" name="PlaceHolder 4"/>
           <p:cNvSpPr>
             <a:spLocks noGrp="1"/>
           </p:cNvSpPr>
@@ -4003,7 +4308,7 @@
         <p:spPr>
           <a:xfrm>
             <a:off x="4645080" y="1535040"/>
-            <a:ext cx="4037760" cy="635760"/>
+            <a:ext cx="4036320" cy="634320"/>
           </a:xfrm>
           <a:prstGeom prst="rect">
             <a:avLst/>
@@ -4076,7 +4381,7 @@
       </p:sp>
       <p:sp>
         <p:nvSpPr>
-          <p:cNvPr id="22" name="PlaceHolder 5"/>
+          <p:cNvPr id="27" name="PlaceHolder 5"/>
           <p:cNvSpPr>
             <a:spLocks noGrp="1"/>
           </p:cNvSpPr>
@@ -4087,7 +4392,7 @@
         <p:spPr>
           <a:xfrm>
             <a:off x="4645080" y="2174760"/>
-            <a:ext cx="4037760" cy="3947400"/>
+            <a:ext cx="4036320" cy="3945960"/>
           </a:xfrm>
           <a:prstGeom prst="rect">
             <a:avLst/>
@@ -4412,18 +4717,18 @@
       </p:sp>
       <p:sp>
         <p:nvSpPr>
-          <p:cNvPr id="23" name="PlaceHolder 6"/>
+          <p:cNvPr id="28" name="PlaceHolder 6"/>
           <p:cNvSpPr>
             <a:spLocks noGrp="1"/>
           </p:cNvSpPr>
           <p:nvPr>
-            <p:ph type="dt" idx="10"/>
+            <p:ph type="dt" idx="13"/>
           </p:nvPr>
         </p:nvSpPr>
         <p:spPr>
           <a:xfrm>
             <a:off x="457200" y="6356520"/>
-            <a:ext cx="2129760" cy="361080"/>
+            <a:ext cx="2128320" cy="359640"/>
           </a:xfrm>
           <a:prstGeom prst="rect">
             <a:avLst/>
@@ -4479,7 +4784,7 @@
                 <a:uFillTx/>
                 <a:latin typeface="Calibri"/>
               </a:rPr>
-              <a:t>&lt;date/time&gt;</a:t>
+              <a:t> </a:t>
             </a:r>
             <a:endParaRPr lang="en-US" sz="1200" b="0" u="none" strike="noStrike">
               <a:solidFill>
@@ -4494,18 +4799,18 @@
       </p:sp>
       <p:sp>
         <p:nvSpPr>
-          <p:cNvPr id="24" name="PlaceHolder 7"/>
+          <p:cNvPr id="29" name="PlaceHolder 7"/>
           <p:cNvSpPr>
             <a:spLocks noGrp="1"/>
           </p:cNvSpPr>
           <p:nvPr>
-            <p:ph type="ftr" idx="11"/>
+            <p:ph type="ftr" idx="14"/>
           </p:nvPr>
         </p:nvSpPr>
         <p:spPr>
           <a:xfrm>
             <a:off x="3124080" y="6356520"/>
-            <a:ext cx="2891520" cy="361080"/>
+            <a:ext cx="2890080" cy="359640"/>
           </a:xfrm>
           <a:prstGeom prst="rect">
             <a:avLst/>
@@ -4557,7 +4862,7 @@
                 <a:uFillTx/>
                 <a:latin typeface="Times New Roman"/>
               </a:rPr>
-              <a:t>&lt;footer&gt;</a:t>
+              <a:t> </a:t>
             </a:r>
             <a:endParaRPr lang="en-US" sz="1400" b="0" u="none" strike="noStrike">
               <a:solidFill>
@@ -4572,18 +4877,18 @@
       </p:sp>
       <p:sp>
         <p:nvSpPr>
-          <p:cNvPr id="25" name="PlaceHolder 8"/>
+          <p:cNvPr id="30" name="PlaceHolder 8"/>
           <p:cNvSpPr>
             <a:spLocks noGrp="1"/>
           </p:cNvSpPr>
           <p:nvPr>
-            <p:ph type="sldNum" idx="12"/>
+            <p:ph type="sldNum" idx="15"/>
           </p:nvPr>
         </p:nvSpPr>
         <p:spPr>
           <a:xfrm>
             <a:off x="6553080" y="6356520"/>
-            <a:ext cx="2129760" cy="361080"/>
+            <a:ext cx="2128320" cy="359640"/>
           </a:xfrm>
           <a:prstGeom prst="rect">
             <a:avLst/>
@@ -4628,7 +4933,7 @@
                 <a:tab pos="0" algn="l"/>
               </a:tabLst>
             </a:pPr>
-            <a:fld id="{D3E309BA-4217-4AB4-9792-E01590E9A186}" type="slidenum">
+            <a:fld id="{2DD2D981-EA97-4FFD-A612-34EBAE6A8B08}" type="slidenum">
               <a:rPr lang="en-US" sz="1200" b="0" u="none" strike="noStrike">
                 <a:solidFill>
                   <a:schemeClr val="dk1">
@@ -4639,7 +4944,7 @@
                 <a:uFillTx/>
                 <a:latin typeface="Calibri"/>
               </a:rPr>
-              <a:t>&lt;number&gt;</a:t>
+              <a:t>3</a:t>
             </a:fld>
             <a:endParaRPr lang="en-US" sz="1200" b="0" u="none" strike="noStrike">
               <a:solidFill>
@@ -4657,7 +4962,7 @@
 </p:sldLayout>
 </file>
 
-<file path=ppt/slideLayouts/slideLayout5.xml><?xml version="1.0" encoding="utf-8"?>
+<file path=ppt/slideLayouts/slideLayout6.xml><?xml version="1.0" encoding="utf-8"?>
 <p:sldLayout xmlns:a="http://schemas.openxmlformats.org/drawingml/2006/main" xmlns:p="http://schemas.openxmlformats.org/presentationml/2006/main" xmlns:r="http://schemas.openxmlformats.org/officeDocument/2006/relationships" xmlns:p14="http://schemas.microsoft.com/office/powerpoint/2010/main" xmlns:p15="http://schemas.microsoft.com/office/powerpoint/2012/main" xmlns:mc="http://schemas.openxmlformats.org/markup-compatibility/2006" type="titleOnly" preserve="1">
   <p:cSld name="Title Only">
     <p:bg>
@@ -4683,7 +4988,7 @@
       </p:grpSpPr>
       <p:sp>
         <p:nvSpPr>
-          <p:cNvPr id="26" name="PlaceHolder 1"/>
+          <p:cNvPr id="31" name="PlaceHolder 1"/>
           <p:cNvSpPr>
             <a:spLocks noGrp="1"/>
           </p:cNvSpPr>
@@ -4694,7 +4999,7 @@
         <p:spPr>
           <a:xfrm>
             <a:off x="457200" y="274680"/>
-            <a:ext cx="8225640" cy="1139040"/>
+            <a:ext cx="8224200" cy="1137600"/>
           </a:xfrm>
           <a:prstGeom prst="rect">
             <a:avLst/>
@@ -4746,7 +5051,18 @@
                 <a:uFillTx/>
                 <a:latin typeface="Calibri"/>
               </a:rPr>
-              <a:t>Click to edit Master title style</a:t>
+              <a:t>Click to edit Master </a:t>
+            </a:r>
+            <a:r>
+              <a:rPr lang="en-US" sz="4400" b="0" u="none" strike="noStrike">
+                <a:solidFill>
+                  <a:schemeClr val="dk1"/>
+                </a:solidFill>
+                <a:effectLst/>
+                <a:uFillTx/>
+                <a:latin typeface="Calibri"/>
+              </a:rPr>
+              <a:t>title style</a:t>
             </a:r>
             <a:endParaRPr lang="en-US" sz="4400" b="0" u="none" strike="noStrike">
               <a:solidFill>
@@ -4761,18 +5077,18 @@
       </p:sp>
       <p:sp>
         <p:nvSpPr>
-          <p:cNvPr id="27" name="PlaceHolder 2"/>
+          <p:cNvPr id="32" name="PlaceHolder 2"/>
           <p:cNvSpPr>
             <a:spLocks noGrp="1"/>
           </p:cNvSpPr>
           <p:nvPr>
-            <p:ph type="dt" idx="13"/>
+            <p:ph type="dt" idx="16"/>
           </p:nvPr>
         </p:nvSpPr>
         <p:spPr>
           <a:xfrm>
             <a:off x="457200" y="6356520"/>
-            <a:ext cx="2129760" cy="361080"/>
+            <a:ext cx="2128320" cy="359640"/>
           </a:xfrm>
           <a:prstGeom prst="rect">
             <a:avLst/>
@@ -4828,7 +5144,7 @@
                 <a:uFillTx/>
                 <a:latin typeface="Calibri"/>
               </a:rPr>
-              <a:t>&lt;date/time&gt;</a:t>
+              <a:t> </a:t>
             </a:r>
             <a:endParaRPr lang="en-US" sz="1200" b="0" u="none" strike="noStrike">
               <a:solidFill>
@@ -4843,18 +5159,18 @@
       </p:sp>
       <p:sp>
         <p:nvSpPr>
-          <p:cNvPr id="28" name="PlaceHolder 3"/>
+          <p:cNvPr id="33" name="PlaceHolder 3"/>
           <p:cNvSpPr>
             <a:spLocks noGrp="1"/>
           </p:cNvSpPr>
           <p:nvPr>
-            <p:ph type="ftr" idx="14"/>
+            <p:ph type="ftr" idx="17"/>
           </p:nvPr>
         </p:nvSpPr>
         <p:spPr>
           <a:xfrm>
             <a:off x="3124080" y="6356520"/>
-            <a:ext cx="2891520" cy="361080"/>
+            <a:ext cx="2890080" cy="359640"/>
           </a:xfrm>
           <a:prstGeom prst="rect">
             <a:avLst/>
@@ -4906,7 +5222,7 @@
                 <a:uFillTx/>
                 <a:latin typeface="Times New Roman"/>
               </a:rPr>
-              <a:t>&lt;footer&gt;</a:t>
+              <a:t> </a:t>
             </a:r>
             <a:endParaRPr lang="en-US" sz="1400" b="0" u="none" strike="noStrike">
               <a:solidFill>
@@ -4921,18 +5237,18 @@
       </p:sp>
       <p:sp>
         <p:nvSpPr>
-          <p:cNvPr id="29" name="PlaceHolder 4"/>
+          <p:cNvPr id="34" name="PlaceHolder 4"/>
           <p:cNvSpPr>
             <a:spLocks noGrp="1"/>
           </p:cNvSpPr>
           <p:nvPr>
-            <p:ph type="sldNum" idx="15"/>
+            <p:ph type="sldNum" idx="18"/>
           </p:nvPr>
         </p:nvSpPr>
         <p:spPr>
           <a:xfrm>
             <a:off x="6553080" y="6356520"/>
-            <a:ext cx="2129760" cy="361080"/>
+            <a:ext cx="2128320" cy="359640"/>
           </a:xfrm>
           <a:prstGeom prst="rect">
             <a:avLst/>
@@ -4977,7 +5293,7 @@
                 <a:tab pos="0" algn="l"/>
               </a:tabLst>
             </a:pPr>
-            <a:fld id="{E9C3CD72-1B59-4C05-B1FA-B9B4C14D0BD7}" type="slidenum">
+            <a:fld id="{72245E89-E27D-413B-8B18-B5FCFF80C7EF}" type="slidenum">
               <a:rPr lang="en-US" sz="1200" b="0" u="none" strike="noStrike">
                 <a:solidFill>
                   <a:schemeClr val="dk1">
@@ -4988,7 +5304,7 @@
                 <a:uFillTx/>
                 <a:latin typeface="Calibri"/>
               </a:rPr>
-              <a:t>&lt;number&gt;</a:t>
+              <a:t>3</a:t>
             </a:fld>
             <a:endParaRPr lang="en-US" sz="1200" b="0" u="none" strike="noStrike">
               <a:solidFill>
@@ -4997,783 +5313,6 @@
               <a:effectLst/>
               <a:uFillTx/>
               <a:latin typeface="Times New Roman"/>
-            </a:endParaRPr>
-          </a:p>
-        </p:txBody>
-      </p:sp>
-    </p:spTree>
-  </p:cSld>
-</p:sldLayout>
-</file>
-
-<file path=ppt/slideLayouts/slideLayout6.xml><?xml version="1.0" encoding="utf-8"?>
-<p:sldLayout xmlns:a="http://schemas.openxmlformats.org/drawingml/2006/main" xmlns:p="http://schemas.openxmlformats.org/presentationml/2006/main" xmlns:r="http://schemas.openxmlformats.org/officeDocument/2006/relationships" xmlns:p14="http://schemas.microsoft.com/office/powerpoint/2010/main" xmlns:p15="http://schemas.microsoft.com/office/powerpoint/2012/main" xmlns:mc="http://schemas.openxmlformats.org/markup-compatibility/2006" type="blank" preserve="1">
-  <p:cSld name="Blank">
-    <p:bg>
-      <p:bgPr>
-        <a:solidFill>
-          <a:srgbClr val="FFFFFF"/>
-        </a:solidFill>
-      </p:bgPr>
-    </p:bg>
-    <p:spTree>
-      <p:nvGrpSpPr>
-        <p:cNvPr id="1" name=""/>
-        <p:cNvGrpSpPr/>
-        <p:nvPr/>
-      </p:nvGrpSpPr>
-      <p:grpSpPr>
-        <a:xfrm>
-          <a:off x="0" y="0"/>
-          <a:ext cx="0" cy="0"/>
-          <a:chOff x="0" y="0"/>
-          <a:chExt cx="0" cy="0"/>
-        </a:xfrm>
-      </p:grpSpPr>
-      <p:sp>
-        <p:nvSpPr>
-          <p:cNvPr id="30" name="PlaceHolder 1"/>
-          <p:cNvSpPr>
-            <a:spLocks noGrp="1"/>
-          </p:cNvSpPr>
-          <p:nvPr>
-            <p:ph type="dt" idx="16"/>
-          </p:nvPr>
-        </p:nvSpPr>
-        <p:spPr>
-          <a:xfrm>
-            <a:off x="457200" y="6356520"/>
-            <a:ext cx="2129760" cy="361080"/>
-          </a:xfrm>
-          <a:prstGeom prst="rect">
-            <a:avLst/>
-          </a:prstGeom>
-          <a:noFill/>
-          <a:ln w="0">
-            <a:noFill/>
-          </a:ln>
-        </p:spPr>
-        <p:txBody>
-          <a:bodyPr lIns="91440" tIns="45720" rIns="91440" bIns="45720" anchor="ctr">
-            <a:noAutofit/>
-          </a:bodyPr>
-          <a:lstStyle>
-            <a:lvl1pPr indent="0" algn="l" defTabSz="457200">
-              <a:lnSpc>
-                <a:spcPct val="100000"/>
-              </a:lnSpc>
-              <a:buNone/>
-              <a:tabLst>
-                <a:tab pos="0" algn="l"/>
-              </a:tabLst>
-              <a:defRPr lang="en-US" sz="1200" b="0" u="none" strike="noStrike">
-                <a:solidFill>
-                  <a:schemeClr val="dk1">
-                    <a:tint val="75000"/>
-                  </a:schemeClr>
-                </a:solidFill>
-                <a:effectLst/>
-                <a:uFillTx/>
-                <a:latin typeface="Calibri"/>
-              </a:defRPr>
-            </a:lvl1pPr>
-          </a:lstStyle>
-          <a:p>
-            <a:pPr indent="0" algn="l" defTabSz="457200">
-              <a:lnSpc>
-                <a:spcPct val="100000"/>
-              </a:lnSpc>
-              <a:buNone/>
-              <a:tabLst>
-                <a:tab pos="0" algn="l"/>
-              </a:tabLst>
-            </a:pPr>
-            <a:r>
-              <a:rPr lang="en-US" sz="1200" b="0" u="none" strike="noStrike">
-                <a:solidFill>
-                  <a:schemeClr val="dk1">
-                    <a:tint val="75000"/>
-                  </a:schemeClr>
-                </a:solidFill>
-                <a:effectLst/>
-                <a:uFillTx/>
-                <a:latin typeface="Calibri"/>
-              </a:rPr>
-              <a:t>&lt;date/time&gt;</a:t>
-            </a:r>
-            <a:endParaRPr lang="en-US" sz="1200" b="0" u="none" strike="noStrike">
-              <a:solidFill>
-                <a:srgbClr val="000000"/>
-              </a:solidFill>
-              <a:effectLst/>
-              <a:uFillTx/>
-              <a:latin typeface="Times New Roman"/>
-            </a:endParaRPr>
-          </a:p>
-        </p:txBody>
-      </p:sp>
-      <p:sp>
-        <p:nvSpPr>
-          <p:cNvPr id="31" name="PlaceHolder 2"/>
-          <p:cNvSpPr>
-            <a:spLocks noGrp="1"/>
-          </p:cNvSpPr>
-          <p:nvPr>
-            <p:ph type="ftr" idx="17"/>
-          </p:nvPr>
-        </p:nvSpPr>
-        <p:spPr>
-          <a:xfrm>
-            <a:off x="3124080" y="6356520"/>
-            <a:ext cx="2891520" cy="361080"/>
-          </a:xfrm>
-          <a:prstGeom prst="rect">
-            <a:avLst/>
-          </a:prstGeom>
-          <a:noFill/>
-          <a:ln w="0">
-            <a:noFill/>
-          </a:ln>
-        </p:spPr>
-        <p:txBody>
-          <a:bodyPr lIns="91440" tIns="45720" rIns="91440" bIns="45720" anchor="ctr">
-            <a:noAutofit/>
-          </a:bodyPr>
-          <a:lstStyle>
-            <a:lvl1pPr indent="0" algn="ctr">
-              <a:lnSpc>
-                <a:spcPct val="100000"/>
-              </a:lnSpc>
-              <a:buNone/>
-              <a:tabLst>
-                <a:tab pos="0" algn="l"/>
-              </a:tabLst>
-              <a:defRPr lang="en-US" sz="1400" b="0" u="none" strike="noStrike">
-                <a:solidFill>
-                  <a:srgbClr val="000000"/>
-                </a:solidFill>
-                <a:effectLst/>
-                <a:uFillTx/>
-                <a:latin typeface="Times New Roman"/>
-              </a:defRPr>
-            </a:lvl1pPr>
-          </a:lstStyle>
-          <a:p>
-            <a:pPr indent="0" algn="ctr">
-              <a:lnSpc>
-                <a:spcPct val="100000"/>
-              </a:lnSpc>
-              <a:buNone/>
-              <a:tabLst>
-                <a:tab pos="0" algn="l"/>
-              </a:tabLst>
-            </a:pPr>
-            <a:r>
-              <a:rPr lang="en-US" sz="1400" b="0" u="none" strike="noStrike">
-                <a:solidFill>
-                  <a:srgbClr val="000000"/>
-                </a:solidFill>
-                <a:effectLst/>
-                <a:uFillTx/>
-                <a:latin typeface="Times New Roman"/>
-              </a:rPr>
-              <a:t>&lt;footer&gt;</a:t>
-            </a:r>
-            <a:endParaRPr lang="en-US" sz="1400" b="0" u="none" strike="noStrike">
-              <a:solidFill>
-                <a:srgbClr val="000000"/>
-              </a:solidFill>
-              <a:effectLst/>
-              <a:uFillTx/>
-              <a:latin typeface="Times New Roman"/>
-            </a:endParaRPr>
-          </a:p>
-        </p:txBody>
-      </p:sp>
-      <p:sp>
-        <p:nvSpPr>
-          <p:cNvPr id="32" name="PlaceHolder 3"/>
-          <p:cNvSpPr>
-            <a:spLocks noGrp="1"/>
-          </p:cNvSpPr>
-          <p:nvPr>
-            <p:ph type="sldNum" idx="18"/>
-          </p:nvPr>
-        </p:nvSpPr>
-        <p:spPr>
-          <a:xfrm>
-            <a:off x="6553080" y="6356520"/>
-            <a:ext cx="2129760" cy="361080"/>
-          </a:xfrm>
-          <a:prstGeom prst="rect">
-            <a:avLst/>
-          </a:prstGeom>
-          <a:noFill/>
-          <a:ln w="0">
-            <a:noFill/>
-          </a:ln>
-        </p:spPr>
-        <p:txBody>
-          <a:bodyPr lIns="91440" tIns="45720" rIns="91440" bIns="45720" anchor="ctr">
-            <a:noAutofit/>
-          </a:bodyPr>
-          <a:lstStyle>
-            <a:lvl1pPr indent="0" algn="r" defTabSz="457200">
-              <a:lnSpc>
-                <a:spcPct val="100000"/>
-              </a:lnSpc>
-              <a:buNone/>
-              <a:tabLst>
-                <a:tab pos="0" algn="l"/>
-              </a:tabLst>
-              <a:defRPr lang="en-US" sz="1200" b="0" u="none" strike="noStrike">
-                <a:solidFill>
-                  <a:schemeClr val="dk1">
-                    <a:tint val="75000"/>
-                  </a:schemeClr>
-                </a:solidFill>
-                <a:effectLst/>
-                <a:uFillTx/>
-                <a:latin typeface="Calibri"/>
-              </a:defRPr>
-            </a:lvl1pPr>
-          </a:lstStyle>
-          <a:p>
-            <a:pPr indent="0" algn="r" defTabSz="457200">
-              <a:lnSpc>
-                <a:spcPct val="100000"/>
-              </a:lnSpc>
-              <a:buNone/>
-              <a:tabLst>
-                <a:tab pos="0" algn="l"/>
-              </a:tabLst>
-            </a:pPr>
-            <a:fld id="{686814E7-AB72-4354-84A9-C6C7E05FCC1A}" type="slidenum">
-              <a:rPr lang="en-US" sz="1200" b="0" u="none" strike="noStrike">
-                <a:solidFill>
-                  <a:schemeClr val="dk1">
-                    <a:tint val="75000"/>
-                  </a:schemeClr>
-                </a:solidFill>
-                <a:effectLst/>
-                <a:uFillTx/>
-                <a:latin typeface="Calibri"/>
-              </a:rPr>
-              <a:t>&lt;number&gt;</a:t>
-            </a:fld>
-            <a:endParaRPr lang="en-US" sz="1200" b="0" u="none" strike="noStrike">
-              <a:solidFill>
-                <a:srgbClr val="000000"/>
-              </a:solidFill>
-              <a:effectLst/>
-              <a:uFillTx/>
-              <a:latin typeface="Times New Roman"/>
-            </a:endParaRPr>
-          </a:p>
-        </p:txBody>
-      </p:sp>
-      <p:sp>
-        <p:nvSpPr>
-          <p:cNvPr id="33" name="PlaceHolder 4"/>
-          <p:cNvSpPr>
-            <a:spLocks noGrp="1"/>
-          </p:cNvSpPr>
-          <p:nvPr>
-            <p:ph type="title"/>
-          </p:nvPr>
-        </p:nvSpPr>
-        <p:spPr>
-          <a:xfrm>
-            <a:off x="609480" y="273600"/>
-            <a:ext cx="10968480" cy="1141200"/>
-          </a:xfrm>
-          <a:prstGeom prst="rect">
-            <a:avLst/>
-          </a:prstGeom>
-          <a:noFill/>
-          <a:ln w="0">
-            <a:noFill/>
-          </a:ln>
-        </p:spPr>
-        <p:txBody>
-          <a:bodyPr lIns="0" tIns="0" rIns="0" bIns="0" anchor="ctr">
-            <a:noAutofit/>
-          </a:bodyPr>
-          <a:lstStyle>
-            <a:lvl1pPr indent="0" algn="ctr" defTabSz="457200">
-              <a:lnSpc>
-                <a:spcPct val="100000"/>
-              </a:lnSpc>
-              <a:buNone/>
-              <a:tabLst>
-                <a:tab pos="0" algn="l"/>
-              </a:tabLst>
-              <a:defRPr lang="en-US" sz="4400" b="0" u="none" strike="noStrike">
-                <a:solidFill>
-                  <a:schemeClr val="dk1"/>
-                </a:solidFill>
-                <a:effectLst/>
-                <a:uFillTx/>
-                <a:latin typeface="Calibri"/>
-              </a:defRPr>
-            </a:lvl1pPr>
-          </a:lstStyle>
-          <a:p>
-            <a:pPr indent="0" algn="ctr" defTabSz="457200">
-              <a:lnSpc>
-                <a:spcPct val="100000"/>
-              </a:lnSpc>
-              <a:buNone/>
-              <a:tabLst>
-                <a:tab pos="0" algn="l"/>
-              </a:tabLst>
-            </a:pPr>
-            <a:r>
-              <a:rPr lang="en-US" sz="4400" b="0" u="none" strike="noStrike">
-                <a:solidFill>
-                  <a:schemeClr val="dk1"/>
-                </a:solidFill>
-                <a:effectLst/>
-                <a:uFillTx/>
-                <a:latin typeface="Calibri"/>
-              </a:rPr>
-              <a:t>Click to edit the title text format</a:t>
-            </a:r>
-            <a:endParaRPr lang="en-US" sz="4400" b="0" u="none" strike="noStrike">
-              <a:solidFill>
-                <a:schemeClr val="dk1"/>
-              </a:solidFill>
-              <a:effectLst/>
-              <a:uFillTx/>
-              <a:latin typeface="Calibri"/>
-            </a:endParaRPr>
-          </a:p>
-        </p:txBody>
-      </p:sp>
-      <p:sp>
-        <p:nvSpPr>
-          <p:cNvPr id="34" name="PlaceHolder 5"/>
-          <p:cNvSpPr>
-            <a:spLocks noGrp="1"/>
-          </p:cNvSpPr>
-          <p:nvPr>
-            <p:ph type="body"/>
-          </p:nvPr>
-        </p:nvSpPr>
-        <p:spPr>
-          <a:xfrm>
-            <a:off x="609480" y="1604520"/>
-            <a:ext cx="10968480" cy="3973680"/>
-          </a:xfrm>
-          <a:prstGeom prst="rect">
-            <a:avLst/>
-          </a:prstGeom>
-          <a:noFill/>
-          <a:ln w="0">
-            <a:noFill/>
-          </a:ln>
-        </p:spPr>
-        <p:txBody>
-          <a:bodyPr lIns="0" tIns="0" rIns="0" bIns="0" anchor="t">
-            <a:normAutofit/>
-          </a:bodyPr>
-          <a:lstStyle>
-            <a:lvl1pPr algn="l" defTabSz="457200">
-              <a:lnSpc>
-                <a:spcPct val="100000"/>
-              </a:lnSpc>
-              <a:spcBef>
-                <a:spcPts val="641"/>
-              </a:spcBef>
-              <a:buClr>
-                <a:srgbClr val="000000"/>
-              </a:buClr>
-              <a:buFont typeface="Arial"/>
-              <a:buChar char="•"/>
-              <a:defRPr lang="en-US" sz="3200" b="0" u="none" strike="noStrike">
-                <a:solidFill>
-                  <a:schemeClr val="dk1"/>
-                </a:solidFill>
-                <a:effectLst/>
-                <a:uFillTx/>
-                <a:latin typeface="Calibri"/>
-              </a:defRPr>
-            </a:lvl1pPr>
-            <a:lvl2pPr lvl="1" algn="l" defTabSz="457200">
-              <a:lnSpc>
-                <a:spcPct val="100000"/>
-              </a:lnSpc>
-              <a:spcBef>
-                <a:spcPts val="561"/>
-              </a:spcBef>
-              <a:buClr>
-                <a:srgbClr val="000000"/>
-              </a:buClr>
-              <a:buSzPct val="75000"/>
-              <a:buFont typeface="Symbol" charset="2"/>
-              <a:buChar char=""/>
-              <a:defRPr lang="en-US" sz="2800" b="0" u="none" strike="noStrike">
-                <a:solidFill>
-                  <a:schemeClr val="dk1"/>
-                </a:solidFill>
-                <a:effectLst/>
-                <a:uFillTx/>
-                <a:latin typeface="Calibri"/>
-              </a:defRPr>
-            </a:lvl2pPr>
-            <a:lvl3pPr lvl="2" algn="l" defTabSz="457200">
-              <a:lnSpc>
-                <a:spcPct val="100000"/>
-              </a:lnSpc>
-              <a:spcBef>
-                <a:spcPts val="479"/>
-              </a:spcBef>
-              <a:buClr>
-                <a:srgbClr val="000000"/>
-              </a:buClr>
-              <a:buSzPct val="45000"/>
-              <a:buFont typeface="Wingdings" charset="2"/>
-              <a:buChar char=""/>
-              <a:defRPr lang="en-US" sz="2400" b="0" u="none" strike="noStrike">
-                <a:solidFill>
-                  <a:schemeClr val="dk1"/>
-                </a:solidFill>
-                <a:effectLst/>
-                <a:uFillTx/>
-                <a:latin typeface="Calibri"/>
-              </a:defRPr>
-            </a:lvl3pPr>
-            <a:lvl4pPr lvl="3" algn="l" defTabSz="457200">
-              <a:lnSpc>
-                <a:spcPct val="100000"/>
-              </a:lnSpc>
-              <a:spcBef>
-                <a:spcPts val="400"/>
-              </a:spcBef>
-              <a:buClr>
-                <a:srgbClr val="000000"/>
-              </a:buClr>
-              <a:buSzPct val="75000"/>
-              <a:buFont typeface="Symbol" charset="2"/>
-              <a:buChar char=""/>
-              <a:defRPr lang="en-US" sz="2000" b="0" u="none" strike="noStrike">
-                <a:solidFill>
-                  <a:schemeClr val="dk1"/>
-                </a:solidFill>
-                <a:effectLst/>
-                <a:uFillTx/>
-                <a:latin typeface="Calibri"/>
-              </a:defRPr>
-            </a:lvl4pPr>
-            <a:lvl5pPr lvl="4" algn="l" defTabSz="457200">
-              <a:lnSpc>
-                <a:spcPct val="100000"/>
-              </a:lnSpc>
-              <a:spcBef>
-                <a:spcPts val="400"/>
-              </a:spcBef>
-              <a:buClr>
-                <a:srgbClr val="000000"/>
-              </a:buClr>
-              <a:buSzPct val="45000"/>
-              <a:buFont typeface="Wingdings" charset="2"/>
-              <a:buChar char=""/>
-              <a:defRPr lang="en-US" sz="2000" b="0" u="none" strike="noStrike">
-                <a:solidFill>
-                  <a:schemeClr val="dk1"/>
-                </a:solidFill>
-                <a:effectLst/>
-                <a:uFillTx/>
-                <a:latin typeface="Calibri"/>
-              </a:defRPr>
-            </a:lvl5pPr>
-            <a:lvl6pPr lvl="5" algn="l" defTabSz="457200">
-              <a:lnSpc>
-                <a:spcPct val="100000"/>
-              </a:lnSpc>
-              <a:spcBef>
-                <a:spcPts val="283"/>
-              </a:spcBef>
-              <a:buClr>
-                <a:srgbClr val="000000"/>
-              </a:buClr>
-              <a:buSzPct val="45000"/>
-              <a:buFont typeface="Wingdings" charset="2"/>
-              <a:buChar char=""/>
-              <a:defRPr lang="en-US" sz="2000" b="0" u="none" strike="noStrike">
-                <a:solidFill>
-                  <a:schemeClr val="dk1"/>
-                </a:solidFill>
-                <a:effectLst/>
-                <a:uFillTx/>
-                <a:latin typeface="Calibri"/>
-              </a:defRPr>
-            </a:lvl6pPr>
-            <a:lvl7pPr lvl="6" algn="l" defTabSz="457200">
-              <a:lnSpc>
-                <a:spcPct val="100000"/>
-              </a:lnSpc>
-              <a:spcBef>
-                <a:spcPts val="283"/>
-              </a:spcBef>
-              <a:buClr>
-                <a:srgbClr val="000000"/>
-              </a:buClr>
-              <a:buSzPct val="45000"/>
-              <a:buFont typeface="Wingdings" charset="2"/>
-              <a:buChar char=""/>
-              <a:defRPr lang="en-US" sz="2000" b="0" u="none" strike="noStrike">
-                <a:solidFill>
-                  <a:schemeClr val="dk1"/>
-                </a:solidFill>
-                <a:effectLst/>
-                <a:uFillTx/>
-                <a:latin typeface="Calibri"/>
-              </a:defRPr>
-            </a:lvl7pPr>
-          </a:lstStyle>
-          <a:p>
-            <a:pPr marL="343080" indent="-343080" algn="l" defTabSz="457200">
-              <a:lnSpc>
-                <a:spcPct val="100000"/>
-              </a:lnSpc>
-              <a:spcBef>
-                <a:spcPts val="641"/>
-              </a:spcBef>
-              <a:buClr>
-                <a:srgbClr val="000000"/>
-              </a:buClr>
-              <a:buFont typeface="Arial"/>
-              <a:buChar char="•"/>
-            </a:pPr>
-            <a:r>
-              <a:rPr lang="en-US" sz="3200" b="0" u="none" strike="noStrike">
-                <a:solidFill>
-                  <a:schemeClr val="dk1"/>
-                </a:solidFill>
-                <a:effectLst/>
-                <a:uFillTx/>
-                <a:latin typeface="Calibri"/>
-              </a:rPr>
-              <a:t>Click to edit the outline text format</a:t>
-            </a:r>
-            <a:endParaRPr lang="en-US" sz="3200" b="0" u="none" strike="noStrike">
-              <a:solidFill>
-                <a:schemeClr val="dk1"/>
-              </a:solidFill>
-              <a:effectLst/>
-              <a:uFillTx/>
-              <a:latin typeface="Calibri"/>
-            </a:endParaRPr>
-          </a:p>
-          <a:p>
-            <a:pPr marL="864000" lvl="1" indent="-324000" algn="l" defTabSz="457200">
-              <a:lnSpc>
-                <a:spcPct val="100000"/>
-              </a:lnSpc>
-              <a:spcBef>
-                <a:spcPts val="561"/>
-              </a:spcBef>
-              <a:buClr>
-                <a:srgbClr val="000000"/>
-              </a:buClr>
-              <a:buSzPct val="75000"/>
-              <a:buFont typeface="Symbol" charset="2"/>
-              <a:buChar char=""/>
-            </a:pPr>
-            <a:r>
-              <a:rPr lang="en-US" sz="2800" b="0" u="none" strike="noStrike">
-                <a:solidFill>
-                  <a:schemeClr val="dk1"/>
-                </a:solidFill>
-                <a:effectLst/>
-                <a:uFillTx/>
-                <a:latin typeface="Calibri"/>
-              </a:rPr>
-              <a:t>Second Outline Level</a:t>
-            </a:r>
-            <a:endParaRPr lang="en-US" sz="2800" b="0" u="none" strike="noStrike">
-              <a:solidFill>
-                <a:schemeClr val="dk1"/>
-              </a:solidFill>
-              <a:effectLst/>
-              <a:uFillTx/>
-              <a:latin typeface="Calibri"/>
-            </a:endParaRPr>
-          </a:p>
-          <a:p>
-            <a:pPr marL="1296000" lvl="2" indent="-288000" algn="l" defTabSz="457200">
-              <a:lnSpc>
-                <a:spcPct val="100000"/>
-              </a:lnSpc>
-              <a:spcBef>
-                <a:spcPts val="479"/>
-              </a:spcBef>
-              <a:buClr>
-                <a:srgbClr val="000000"/>
-              </a:buClr>
-              <a:buSzPct val="45000"/>
-              <a:buFont typeface="Wingdings" charset="2"/>
-              <a:buChar char=""/>
-            </a:pPr>
-            <a:r>
-              <a:rPr lang="en-US" sz="2400" b="0" u="none" strike="noStrike">
-                <a:solidFill>
-                  <a:schemeClr val="dk1"/>
-                </a:solidFill>
-                <a:effectLst/>
-                <a:uFillTx/>
-                <a:latin typeface="Calibri"/>
-              </a:rPr>
-              <a:t>Third Outline Level</a:t>
-            </a:r>
-            <a:endParaRPr lang="en-US" sz="2400" b="0" u="none" strike="noStrike">
-              <a:solidFill>
-                <a:schemeClr val="dk1"/>
-              </a:solidFill>
-              <a:effectLst/>
-              <a:uFillTx/>
-              <a:latin typeface="Calibri"/>
-            </a:endParaRPr>
-          </a:p>
-          <a:p>
-            <a:pPr marL="1728000" lvl="3" indent="-216000" algn="l" defTabSz="457200">
-              <a:lnSpc>
-                <a:spcPct val="100000"/>
-              </a:lnSpc>
-              <a:spcBef>
-                <a:spcPts val="400"/>
-              </a:spcBef>
-              <a:buClr>
-                <a:srgbClr val="000000"/>
-              </a:buClr>
-              <a:buSzPct val="75000"/>
-              <a:buFont typeface="Symbol" charset="2"/>
-              <a:buChar char=""/>
-            </a:pPr>
-            <a:r>
-              <a:rPr lang="en-US" sz="2000" b="0" u="none" strike="noStrike">
-                <a:solidFill>
-                  <a:schemeClr val="dk1"/>
-                </a:solidFill>
-                <a:effectLst/>
-                <a:uFillTx/>
-                <a:latin typeface="Calibri"/>
-              </a:rPr>
-              <a:t>Fourth Outline Level</a:t>
-            </a:r>
-            <a:endParaRPr lang="en-US" sz="2000" b="0" u="none" strike="noStrike">
-              <a:solidFill>
-                <a:schemeClr val="dk1"/>
-              </a:solidFill>
-              <a:effectLst/>
-              <a:uFillTx/>
-              <a:latin typeface="Calibri"/>
-            </a:endParaRPr>
-          </a:p>
-          <a:p>
-            <a:pPr marL="2160000" lvl="4" indent="-216000" algn="l" defTabSz="457200">
-              <a:lnSpc>
-                <a:spcPct val="100000"/>
-              </a:lnSpc>
-              <a:spcBef>
-                <a:spcPts val="400"/>
-              </a:spcBef>
-              <a:buClr>
-                <a:srgbClr val="000000"/>
-              </a:buClr>
-              <a:buSzPct val="45000"/>
-              <a:buFont typeface="Wingdings" charset="2"/>
-              <a:buChar char=""/>
-            </a:pPr>
-            <a:r>
-              <a:rPr lang="en-US" sz="2000" b="0" u="none" strike="noStrike">
-                <a:solidFill>
-                  <a:schemeClr val="dk1"/>
-                </a:solidFill>
-                <a:effectLst/>
-                <a:uFillTx/>
-                <a:latin typeface="Calibri"/>
-              </a:rPr>
-              <a:t>Fifth Outline Level</a:t>
-            </a:r>
-            <a:endParaRPr lang="en-US" sz="2000" b="0" u="none" strike="noStrike">
-              <a:solidFill>
-                <a:schemeClr val="dk1"/>
-              </a:solidFill>
-              <a:effectLst/>
-              <a:uFillTx/>
-              <a:latin typeface="Calibri"/>
-            </a:endParaRPr>
-          </a:p>
-          <a:p>
-            <a:pPr marL="2592000" lvl="5" indent="-216000" algn="l" defTabSz="457200">
-              <a:lnSpc>
-                <a:spcPct val="100000"/>
-              </a:lnSpc>
-              <a:spcBef>
-                <a:spcPts val="283"/>
-              </a:spcBef>
-              <a:buClr>
-                <a:srgbClr val="000000"/>
-              </a:buClr>
-              <a:buSzPct val="45000"/>
-              <a:buFont typeface="Wingdings" charset="2"/>
-              <a:buChar char=""/>
-            </a:pPr>
-            <a:r>
-              <a:rPr lang="en-US" sz="2000" b="0" u="none" strike="noStrike">
-                <a:solidFill>
-                  <a:schemeClr val="dk1"/>
-                </a:solidFill>
-                <a:effectLst/>
-                <a:uFillTx/>
-                <a:latin typeface="Calibri"/>
-              </a:rPr>
-              <a:t>Sixth Outline Level</a:t>
-            </a:r>
-            <a:endParaRPr lang="en-US" sz="2000" b="0" u="none" strike="noStrike">
-              <a:solidFill>
-                <a:schemeClr val="dk1"/>
-              </a:solidFill>
-              <a:effectLst/>
-              <a:uFillTx/>
-              <a:latin typeface="Calibri"/>
-            </a:endParaRPr>
-          </a:p>
-          <a:p>
-            <a:pPr marL="3024000" lvl="6" indent="-216000" algn="l" defTabSz="457200">
-              <a:lnSpc>
-                <a:spcPct val="100000"/>
-              </a:lnSpc>
-              <a:spcBef>
-                <a:spcPts val="283"/>
-              </a:spcBef>
-              <a:buClr>
-                <a:srgbClr val="000000"/>
-              </a:buClr>
-              <a:buSzPct val="45000"/>
-              <a:buFont typeface="Wingdings" charset="2"/>
-              <a:buChar char=""/>
-            </a:pPr>
-            <a:r>
-              <a:rPr lang="en-US" sz="2000" b="0" u="none" strike="noStrike">
-                <a:solidFill>
-                  <a:schemeClr val="dk1"/>
-                </a:solidFill>
-                <a:effectLst/>
-                <a:uFillTx/>
-                <a:latin typeface="Calibri"/>
-              </a:rPr>
-              <a:t>Seventh Outline Level</a:t>
-            </a:r>
-            <a:endParaRPr lang="en-US" sz="2000" b="0" u="none" strike="noStrike">
-              <a:solidFill>
-                <a:schemeClr val="dk1"/>
-              </a:solidFill>
-              <a:effectLst/>
-              <a:uFillTx/>
-              <a:latin typeface="Calibri"/>
             </a:endParaRPr>
           </a:p>
         </p:txBody>
@@ -5785,7 +5324,7 @@
 
 <file path=ppt/slideLayouts/slideLayout7.xml><?xml version="1.0" encoding="utf-8"?>
 <p:sldLayout xmlns:a="http://schemas.openxmlformats.org/drawingml/2006/main" xmlns:p="http://schemas.openxmlformats.org/presentationml/2006/main" xmlns:r="http://schemas.openxmlformats.org/officeDocument/2006/relationships" xmlns:p14="http://schemas.microsoft.com/office/powerpoint/2010/main" xmlns:p15="http://schemas.microsoft.com/office/powerpoint/2012/main" xmlns:mc="http://schemas.openxmlformats.org/markup-compatibility/2006" type="blank" preserve="1">
-  <p:cSld name="Content with Caption">
+  <p:cSld name="Blank">
     <p:bg>
       <p:bgPr>
         <a:solidFill>
@@ -5814,13 +5353,801 @@
             <a:spLocks noGrp="1"/>
           </p:cNvSpPr>
           <p:nvPr>
+            <p:ph type="dt" idx="19"/>
+          </p:nvPr>
+        </p:nvSpPr>
+        <p:spPr>
+          <a:xfrm>
+            <a:off x="457200" y="6356520"/>
+            <a:ext cx="2128320" cy="359640"/>
+          </a:xfrm>
+          <a:prstGeom prst="rect">
+            <a:avLst/>
+          </a:prstGeom>
+          <a:noFill/>
+          <a:ln w="0">
+            <a:noFill/>
+          </a:ln>
+        </p:spPr>
+        <p:txBody>
+          <a:bodyPr lIns="91440" tIns="45720" rIns="91440" bIns="45720" anchor="ctr">
+            <a:noAutofit/>
+          </a:bodyPr>
+          <a:lstStyle>
+            <a:lvl1pPr indent="0" algn="l" defTabSz="457200">
+              <a:lnSpc>
+                <a:spcPct val="100000"/>
+              </a:lnSpc>
+              <a:buNone/>
+              <a:tabLst>
+                <a:tab pos="0" algn="l"/>
+              </a:tabLst>
+              <a:defRPr lang="en-US" sz="1200" b="0" u="none" strike="noStrike">
+                <a:solidFill>
+                  <a:schemeClr val="dk1">
+                    <a:tint val="75000"/>
+                  </a:schemeClr>
+                </a:solidFill>
+                <a:effectLst/>
+                <a:uFillTx/>
+                <a:latin typeface="Calibri"/>
+              </a:defRPr>
+            </a:lvl1pPr>
+          </a:lstStyle>
+          <a:p>
+            <a:pPr indent="0" algn="l" defTabSz="457200">
+              <a:lnSpc>
+                <a:spcPct val="100000"/>
+              </a:lnSpc>
+              <a:buNone/>
+              <a:tabLst>
+                <a:tab pos="0" algn="l"/>
+              </a:tabLst>
+            </a:pPr>
+            <a:r>
+              <a:rPr lang="en-US" sz="1200" b="0" u="none" strike="noStrike">
+                <a:solidFill>
+                  <a:schemeClr val="dk1">
+                    <a:tint val="75000"/>
+                  </a:schemeClr>
+                </a:solidFill>
+                <a:effectLst/>
+                <a:uFillTx/>
+                <a:latin typeface="Calibri"/>
+              </a:rPr>
+              <a:t> </a:t>
+            </a:r>
+            <a:endParaRPr lang="en-US" sz="1200" b="0" u="none" strike="noStrike">
+              <a:solidFill>
+                <a:srgbClr val="000000"/>
+              </a:solidFill>
+              <a:effectLst/>
+              <a:uFillTx/>
+              <a:latin typeface="Times New Roman"/>
+            </a:endParaRPr>
+          </a:p>
+        </p:txBody>
+      </p:sp>
+      <p:sp>
+        <p:nvSpPr>
+          <p:cNvPr id="36" name="PlaceHolder 2"/>
+          <p:cNvSpPr>
+            <a:spLocks noGrp="1"/>
+          </p:cNvSpPr>
+          <p:nvPr>
+            <p:ph type="ftr" idx="20"/>
+          </p:nvPr>
+        </p:nvSpPr>
+        <p:spPr>
+          <a:xfrm>
+            <a:off x="3124080" y="6356520"/>
+            <a:ext cx="2890080" cy="359640"/>
+          </a:xfrm>
+          <a:prstGeom prst="rect">
+            <a:avLst/>
+          </a:prstGeom>
+          <a:noFill/>
+          <a:ln w="0">
+            <a:noFill/>
+          </a:ln>
+        </p:spPr>
+        <p:txBody>
+          <a:bodyPr lIns="91440" tIns="45720" rIns="91440" bIns="45720" anchor="ctr">
+            <a:noAutofit/>
+          </a:bodyPr>
+          <a:lstStyle>
+            <a:lvl1pPr indent="0" algn="ctr">
+              <a:lnSpc>
+                <a:spcPct val="100000"/>
+              </a:lnSpc>
+              <a:buNone/>
+              <a:tabLst>
+                <a:tab pos="0" algn="l"/>
+              </a:tabLst>
+              <a:defRPr lang="en-US" sz="1400" b="0" u="none" strike="noStrike">
+                <a:solidFill>
+                  <a:srgbClr val="000000"/>
+                </a:solidFill>
+                <a:effectLst/>
+                <a:uFillTx/>
+                <a:latin typeface="Times New Roman"/>
+              </a:defRPr>
+            </a:lvl1pPr>
+          </a:lstStyle>
+          <a:p>
+            <a:pPr indent="0" algn="ctr">
+              <a:lnSpc>
+                <a:spcPct val="100000"/>
+              </a:lnSpc>
+              <a:buNone/>
+              <a:tabLst>
+                <a:tab pos="0" algn="l"/>
+              </a:tabLst>
+            </a:pPr>
+            <a:r>
+              <a:rPr lang="en-US" sz="1400" b="0" u="none" strike="noStrike">
+                <a:solidFill>
+                  <a:srgbClr val="000000"/>
+                </a:solidFill>
+                <a:effectLst/>
+                <a:uFillTx/>
+                <a:latin typeface="Times New Roman"/>
+              </a:rPr>
+              <a:t> </a:t>
+            </a:r>
+            <a:endParaRPr lang="en-US" sz="1400" b="0" u="none" strike="noStrike">
+              <a:solidFill>
+                <a:srgbClr val="000000"/>
+              </a:solidFill>
+              <a:effectLst/>
+              <a:uFillTx/>
+              <a:latin typeface="Times New Roman"/>
+            </a:endParaRPr>
+          </a:p>
+        </p:txBody>
+      </p:sp>
+      <p:sp>
+        <p:nvSpPr>
+          <p:cNvPr id="37" name="PlaceHolder 3"/>
+          <p:cNvSpPr>
+            <a:spLocks noGrp="1"/>
+          </p:cNvSpPr>
+          <p:nvPr>
+            <p:ph type="sldNum" idx="21"/>
+          </p:nvPr>
+        </p:nvSpPr>
+        <p:spPr>
+          <a:xfrm>
+            <a:off x="6553080" y="6356520"/>
+            <a:ext cx="2128320" cy="359640"/>
+          </a:xfrm>
+          <a:prstGeom prst="rect">
+            <a:avLst/>
+          </a:prstGeom>
+          <a:noFill/>
+          <a:ln w="0">
+            <a:noFill/>
+          </a:ln>
+        </p:spPr>
+        <p:txBody>
+          <a:bodyPr lIns="91440" tIns="45720" rIns="91440" bIns="45720" anchor="ctr">
+            <a:noAutofit/>
+          </a:bodyPr>
+          <a:lstStyle>
+            <a:lvl1pPr indent="0" algn="r" defTabSz="457200">
+              <a:lnSpc>
+                <a:spcPct val="100000"/>
+              </a:lnSpc>
+              <a:buNone/>
+              <a:tabLst>
+                <a:tab pos="0" algn="l"/>
+              </a:tabLst>
+              <a:defRPr lang="en-US" sz="1200" b="0" u="none" strike="noStrike">
+                <a:solidFill>
+                  <a:schemeClr val="dk1">
+                    <a:tint val="75000"/>
+                  </a:schemeClr>
+                </a:solidFill>
+                <a:effectLst/>
+                <a:uFillTx/>
+                <a:latin typeface="Calibri"/>
+              </a:defRPr>
+            </a:lvl1pPr>
+          </a:lstStyle>
+          <a:p>
+            <a:pPr indent="0" algn="r" defTabSz="457200">
+              <a:lnSpc>
+                <a:spcPct val="100000"/>
+              </a:lnSpc>
+              <a:buNone/>
+              <a:tabLst>
+                <a:tab pos="0" algn="l"/>
+              </a:tabLst>
+            </a:pPr>
+            <a:fld id="{2D92955A-71AF-4834-9F05-AB5C0BD358D6}" type="slidenum">
+              <a:rPr lang="en-US" sz="1200" b="0" u="none" strike="noStrike">
+                <a:solidFill>
+                  <a:schemeClr val="dk1">
+                    <a:tint val="75000"/>
+                  </a:schemeClr>
+                </a:solidFill>
+                <a:effectLst/>
+                <a:uFillTx/>
+                <a:latin typeface="Calibri"/>
+              </a:rPr>
+              <a:t>3</a:t>
+            </a:fld>
+            <a:endParaRPr lang="en-US" sz="1200" b="0" u="none" strike="noStrike">
+              <a:solidFill>
+                <a:srgbClr val="000000"/>
+              </a:solidFill>
+              <a:effectLst/>
+              <a:uFillTx/>
+              <a:latin typeface="Times New Roman"/>
+            </a:endParaRPr>
+          </a:p>
+        </p:txBody>
+      </p:sp>
+      <p:sp>
+        <p:nvSpPr>
+          <p:cNvPr id="38" name="PlaceHolder 4"/>
+          <p:cNvSpPr>
+            <a:spLocks noGrp="1"/>
+          </p:cNvSpPr>
+          <p:nvPr>
+            <p:ph type="title"/>
+          </p:nvPr>
+        </p:nvSpPr>
+        <p:spPr>
+          <a:xfrm>
+            <a:off x="609480" y="273600"/>
+            <a:ext cx="10967040" cy="1139760"/>
+          </a:xfrm>
+          <a:prstGeom prst="rect">
+            <a:avLst/>
+          </a:prstGeom>
+          <a:noFill/>
+          <a:ln w="0">
+            <a:noFill/>
+          </a:ln>
+        </p:spPr>
+        <p:txBody>
+          <a:bodyPr lIns="0" tIns="0" rIns="0" bIns="0" anchor="ctr">
+            <a:noAutofit/>
+          </a:bodyPr>
+          <a:lstStyle>
+            <a:lvl1pPr indent="0" algn="ctr" defTabSz="457200">
+              <a:lnSpc>
+                <a:spcPct val="100000"/>
+              </a:lnSpc>
+              <a:buNone/>
+              <a:tabLst>
+                <a:tab pos="0" algn="l"/>
+              </a:tabLst>
+              <a:defRPr lang="en-US" sz="4400" b="0" u="none" strike="noStrike">
+                <a:solidFill>
+                  <a:schemeClr val="dk1"/>
+                </a:solidFill>
+                <a:effectLst/>
+                <a:uFillTx/>
+                <a:latin typeface="Calibri"/>
+              </a:defRPr>
+            </a:lvl1pPr>
+          </a:lstStyle>
+          <a:p>
+            <a:pPr indent="0" algn="ctr" defTabSz="457200">
+              <a:lnSpc>
+                <a:spcPct val="100000"/>
+              </a:lnSpc>
+              <a:buNone/>
+              <a:tabLst>
+                <a:tab pos="0" algn="l"/>
+              </a:tabLst>
+            </a:pPr>
+            <a:r>
+              <a:rPr lang="en-US" sz="4400" b="0" u="none" strike="noStrike">
+                <a:solidFill>
+                  <a:schemeClr val="dk1"/>
+                </a:solidFill>
+                <a:effectLst/>
+                <a:uFillTx/>
+                <a:latin typeface="Calibri"/>
+              </a:rPr>
+              <a:t>Click to edit the </a:t>
+            </a:r>
+            <a:r>
+              <a:rPr lang="en-US" sz="4400" b="0" u="none" strike="noStrike">
+                <a:solidFill>
+                  <a:schemeClr val="dk1"/>
+                </a:solidFill>
+                <a:effectLst/>
+                <a:uFillTx/>
+                <a:latin typeface="Calibri"/>
+              </a:rPr>
+              <a:t>title text format</a:t>
+            </a:r>
+            <a:endParaRPr lang="en-US" sz="4400" b="0" u="none" strike="noStrike">
+              <a:solidFill>
+                <a:schemeClr val="dk1"/>
+              </a:solidFill>
+              <a:effectLst/>
+              <a:uFillTx/>
+              <a:latin typeface="Calibri"/>
+            </a:endParaRPr>
+          </a:p>
+        </p:txBody>
+      </p:sp>
+      <p:sp>
+        <p:nvSpPr>
+          <p:cNvPr id="39" name="PlaceHolder 5"/>
+          <p:cNvSpPr>
+            <a:spLocks noGrp="1"/>
+          </p:cNvSpPr>
+          <p:nvPr>
+            <p:ph type="body"/>
+          </p:nvPr>
+        </p:nvSpPr>
+        <p:spPr>
+          <a:xfrm>
+            <a:off x="609480" y="1604520"/>
+            <a:ext cx="10967040" cy="3972240"/>
+          </a:xfrm>
+          <a:prstGeom prst="rect">
+            <a:avLst/>
+          </a:prstGeom>
+          <a:noFill/>
+          <a:ln w="0">
+            <a:noFill/>
+          </a:ln>
+        </p:spPr>
+        <p:txBody>
+          <a:bodyPr lIns="0" tIns="0" rIns="0" bIns="0" anchor="t">
+            <a:normAutofit/>
+          </a:bodyPr>
+          <a:lstStyle>
+            <a:lvl1pPr algn="l" defTabSz="457200">
+              <a:lnSpc>
+                <a:spcPct val="100000"/>
+              </a:lnSpc>
+              <a:spcBef>
+                <a:spcPts val="641"/>
+              </a:spcBef>
+              <a:buClr>
+                <a:srgbClr val="000000"/>
+              </a:buClr>
+              <a:buFont typeface="Arial"/>
+              <a:buChar char="•"/>
+              <a:defRPr lang="en-US" sz="3200" b="0" u="none" strike="noStrike">
+                <a:solidFill>
+                  <a:schemeClr val="dk1"/>
+                </a:solidFill>
+                <a:effectLst/>
+                <a:uFillTx/>
+                <a:latin typeface="Calibri"/>
+              </a:defRPr>
+            </a:lvl1pPr>
+            <a:lvl2pPr lvl="1" algn="l" defTabSz="457200">
+              <a:lnSpc>
+                <a:spcPct val="100000"/>
+              </a:lnSpc>
+              <a:spcBef>
+                <a:spcPts val="561"/>
+              </a:spcBef>
+              <a:buClr>
+                <a:srgbClr val="000000"/>
+              </a:buClr>
+              <a:buSzPct val="75000"/>
+              <a:buFont typeface="Symbol" charset="2"/>
+              <a:buChar char=""/>
+              <a:defRPr lang="en-US" sz="2800" b="0" u="none" strike="noStrike">
+                <a:solidFill>
+                  <a:schemeClr val="dk1"/>
+                </a:solidFill>
+                <a:effectLst/>
+                <a:uFillTx/>
+                <a:latin typeface="Calibri"/>
+              </a:defRPr>
+            </a:lvl2pPr>
+            <a:lvl3pPr lvl="2" algn="l" defTabSz="457200">
+              <a:lnSpc>
+                <a:spcPct val="100000"/>
+              </a:lnSpc>
+              <a:spcBef>
+                <a:spcPts val="479"/>
+              </a:spcBef>
+              <a:buClr>
+                <a:srgbClr val="000000"/>
+              </a:buClr>
+              <a:buSzPct val="45000"/>
+              <a:buFont typeface="Wingdings" charset="2"/>
+              <a:buChar char=""/>
+              <a:defRPr lang="en-US" sz="2400" b="0" u="none" strike="noStrike">
+                <a:solidFill>
+                  <a:schemeClr val="dk1"/>
+                </a:solidFill>
+                <a:effectLst/>
+                <a:uFillTx/>
+                <a:latin typeface="Calibri"/>
+              </a:defRPr>
+            </a:lvl3pPr>
+            <a:lvl4pPr lvl="3" algn="l" defTabSz="457200">
+              <a:lnSpc>
+                <a:spcPct val="100000"/>
+              </a:lnSpc>
+              <a:spcBef>
+                <a:spcPts val="400"/>
+              </a:spcBef>
+              <a:buClr>
+                <a:srgbClr val="000000"/>
+              </a:buClr>
+              <a:buSzPct val="75000"/>
+              <a:buFont typeface="Symbol" charset="2"/>
+              <a:buChar char=""/>
+              <a:defRPr lang="en-US" sz="2000" b="0" u="none" strike="noStrike">
+                <a:solidFill>
+                  <a:schemeClr val="dk1"/>
+                </a:solidFill>
+                <a:effectLst/>
+                <a:uFillTx/>
+                <a:latin typeface="Calibri"/>
+              </a:defRPr>
+            </a:lvl4pPr>
+            <a:lvl5pPr lvl="4" algn="l" defTabSz="457200">
+              <a:lnSpc>
+                <a:spcPct val="100000"/>
+              </a:lnSpc>
+              <a:spcBef>
+                <a:spcPts val="400"/>
+              </a:spcBef>
+              <a:buClr>
+                <a:srgbClr val="000000"/>
+              </a:buClr>
+              <a:buSzPct val="45000"/>
+              <a:buFont typeface="Wingdings" charset="2"/>
+              <a:buChar char=""/>
+              <a:defRPr lang="en-US" sz="2000" b="0" u="none" strike="noStrike">
+                <a:solidFill>
+                  <a:schemeClr val="dk1"/>
+                </a:solidFill>
+                <a:effectLst/>
+                <a:uFillTx/>
+                <a:latin typeface="Calibri"/>
+              </a:defRPr>
+            </a:lvl5pPr>
+            <a:lvl6pPr lvl="5" algn="l" defTabSz="457200">
+              <a:lnSpc>
+                <a:spcPct val="100000"/>
+              </a:lnSpc>
+              <a:spcBef>
+                <a:spcPts val="283"/>
+              </a:spcBef>
+              <a:buClr>
+                <a:srgbClr val="000000"/>
+              </a:buClr>
+              <a:buSzPct val="45000"/>
+              <a:buFont typeface="Wingdings" charset="2"/>
+              <a:buChar char=""/>
+              <a:defRPr lang="en-US" sz="2000" b="0" u="none" strike="noStrike">
+                <a:solidFill>
+                  <a:schemeClr val="dk1"/>
+                </a:solidFill>
+                <a:effectLst/>
+                <a:uFillTx/>
+                <a:latin typeface="Calibri"/>
+              </a:defRPr>
+            </a:lvl6pPr>
+            <a:lvl7pPr lvl="6" algn="l" defTabSz="457200">
+              <a:lnSpc>
+                <a:spcPct val="100000"/>
+              </a:lnSpc>
+              <a:spcBef>
+                <a:spcPts val="283"/>
+              </a:spcBef>
+              <a:buClr>
+                <a:srgbClr val="000000"/>
+              </a:buClr>
+              <a:buSzPct val="45000"/>
+              <a:buFont typeface="Wingdings" charset="2"/>
+              <a:buChar char=""/>
+              <a:defRPr lang="en-US" sz="2000" b="0" u="none" strike="noStrike">
+                <a:solidFill>
+                  <a:schemeClr val="dk1"/>
+                </a:solidFill>
+                <a:effectLst/>
+                <a:uFillTx/>
+                <a:latin typeface="Calibri"/>
+              </a:defRPr>
+            </a:lvl7pPr>
+          </a:lstStyle>
+          <a:p>
+            <a:pPr marL="343080" indent="-343080" algn="l" defTabSz="457200">
+              <a:lnSpc>
+                <a:spcPct val="100000"/>
+              </a:lnSpc>
+              <a:spcBef>
+                <a:spcPts val="641"/>
+              </a:spcBef>
+              <a:buClr>
+                <a:srgbClr val="000000"/>
+              </a:buClr>
+              <a:buFont typeface="Arial"/>
+              <a:buChar char="•"/>
+            </a:pPr>
+            <a:r>
+              <a:rPr lang="en-US" sz="3200" b="0" u="none" strike="noStrike">
+                <a:solidFill>
+                  <a:schemeClr val="dk1"/>
+                </a:solidFill>
+                <a:effectLst/>
+                <a:uFillTx/>
+                <a:latin typeface="Calibri"/>
+              </a:rPr>
+              <a:t>Click to edit the outline text format</a:t>
+            </a:r>
+            <a:endParaRPr lang="en-US" sz="3200" b="0" u="none" strike="noStrike">
+              <a:solidFill>
+                <a:schemeClr val="dk1"/>
+              </a:solidFill>
+              <a:effectLst/>
+              <a:uFillTx/>
+              <a:latin typeface="Calibri"/>
+            </a:endParaRPr>
+          </a:p>
+          <a:p>
+            <a:pPr marL="864000" lvl="1" indent="-324000" algn="l" defTabSz="457200">
+              <a:lnSpc>
+                <a:spcPct val="100000"/>
+              </a:lnSpc>
+              <a:spcBef>
+                <a:spcPts val="561"/>
+              </a:spcBef>
+              <a:buClr>
+                <a:srgbClr val="000000"/>
+              </a:buClr>
+              <a:buSzPct val="75000"/>
+              <a:buFont typeface="Symbol" charset="2"/>
+              <a:buChar char=""/>
+            </a:pPr>
+            <a:r>
+              <a:rPr lang="en-US" sz="2800" b="0" u="none" strike="noStrike">
+                <a:solidFill>
+                  <a:schemeClr val="dk1"/>
+                </a:solidFill>
+                <a:effectLst/>
+                <a:uFillTx/>
+                <a:latin typeface="Calibri"/>
+              </a:rPr>
+              <a:t>Second Outline Level</a:t>
+            </a:r>
+            <a:endParaRPr lang="en-US" sz="2800" b="0" u="none" strike="noStrike">
+              <a:solidFill>
+                <a:schemeClr val="dk1"/>
+              </a:solidFill>
+              <a:effectLst/>
+              <a:uFillTx/>
+              <a:latin typeface="Calibri"/>
+            </a:endParaRPr>
+          </a:p>
+          <a:p>
+            <a:pPr marL="1296000" lvl="2" indent="-288000" algn="l" defTabSz="457200">
+              <a:lnSpc>
+                <a:spcPct val="100000"/>
+              </a:lnSpc>
+              <a:spcBef>
+                <a:spcPts val="479"/>
+              </a:spcBef>
+              <a:buClr>
+                <a:srgbClr val="000000"/>
+              </a:buClr>
+              <a:buSzPct val="45000"/>
+              <a:buFont typeface="Wingdings" charset="2"/>
+              <a:buChar char=""/>
+            </a:pPr>
+            <a:r>
+              <a:rPr lang="en-US" sz="2400" b="0" u="none" strike="noStrike">
+                <a:solidFill>
+                  <a:schemeClr val="dk1"/>
+                </a:solidFill>
+                <a:effectLst/>
+                <a:uFillTx/>
+                <a:latin typeface="Calibri"/>
+              </a:rPr>
+              <a:t>Third Outline Level</a:t>
+            </a:r>
+            <a:endParaRPr lang="en-US" sz="2400" b="0" u="none" strike="noStrike">
+              <a:solidFill>
+                <a:schemeClr val="dk1"/>
+              </a:solidFill>
+              <a:effectLst/>
+              <a:uFillTx/>
+              <a:latin typeface="Calibri"/>
+            </a:endParaRPr>
+          </a:p>
+          <a:p>
+            <a:pPr marL="1728000" lvl="3" indent="-216000" algn="l" defTabSz="457200">
+              <a:lnSpc>
+                <a:spcPct val="100000"/>
+              </a:lnSpc>
+              <a:spcBef>
+                <a:spcPts val="400"/>
+              </a:spcBef>
+              <a:buClr>
+                <a:srgbClr val="000000"/>
+              </a:buClr>
+              <a:buSzPct val="75000"/>
+              <a:buFont typeface="Symbol" charset="2"/>
+              <a:buChar char=""/>
+            </a:pPr>
+            <a:r>
+              <a:rPr lang="en-US" sz="2000" b="0" u="none" strike="noStrike">
+                <a:solidFill>
+                  <a:schemeClr val="dk1"/>
+                </a:solidFill>
+                <a:effectLst/>
+                <a:uFillTx/>
+                <a:latin typeface="Calibri"/>
+              </a:rPr>
+              <a:t>Fourth Outline Level</a:t>
+            </a:r>
+            <a:endParaRPr lang="en-US" sz="2000" b="0" u="none" strike="noStrike">
+              <a:solidFill>
+                <a:schemeClr val="dk1"/>
+              </a:solidFill>
+              <a:effectLst/>
+              <a:uFillTx/>
+              <a:latin typeface="Calibri"/>
+            </a:endParaRPr>
+          </a:p>
+          <a:p>
+            <a:pPr marL="2160000" lvl="4" indent="-216000" algn="l" defTabSz="457200">
+              <a:lnSpc>
+                <a:spcPct val="100000"/>
+              </a:lnSpc>
+              <a:spcBef>
+                <a:spcPts val="400"/>
+              </a:spcBef>
+              <a:buClr>
+                <a:srgbClr val="000000"/>
+              </a:buClr>
+              <a:buSzPct val="45000"/>
+              <a:buFont typeface="Wingdings" charset="2"/>
+              <a:buChar char=""/>
+            </a:pPr>
+            <a:r>
+              <a:rPr lang="en-US" sz="2000" b="0" u="none" strike="noStrike">
+                <a:solidFill>
+                  <a:schemeClr val="dk1"/>
+                </a:solidFill>
+                <a:effectLst/>
+                <a:uFillTx/>
+                <a:latin typeface="Calibri"/>
+              </a:rPr>
+              <a:t>Fifth Outline Level</a:t>
+            </a:r>
+            <a:endParaRPr lang="en-US" sz="2000" b="0" u="none" strike="noStrike">
+              <a:solidFill>
+                <a:schemeClr val="dk1"/>
+              </a:solidFill>
+              <a:effectLst/>
+              <a:uFillTx/>
+              <a:latin typeface="Calibri"/>
+            </a:endParaRPr>
+          </a:p>
+          <a:p>
+            <a:pPr marL="2592000" lvl="5" indent="-216000" algn="l" defTabSz="457200">
+              <a:lnSpc>
+                <a:spcPct val="100000"/>
+              </a:lnSpc>
+              <a:spcBef>
+                <a:spcPts val="283"/>
+              </a:spcBef>
+              <a:buClr>
+                <a:srgbClr val="000000"/>
+              </a:buClr>
+              <a:buSzPct val="45000"/>
+              <a:buFont typeface="Wingdings" charset="2"/>
+              <a:buChar char=""/>
+            </a:pPr>
+            <a:r>
+              <a:rPr lang="en-US" sz="2000" b="0" u="none" strike="noStrike">
+                <a:solidFill>
+                  <a:schemeClr val="dk1"/>
+                </a:solidFill>
+                <a:effectLst/>
+                <a:uFillTx/>
+                <a:latin typeface="Calibri"/>
+              </a:rPr>
+              <a:t>Sixth Outline Level</a:t>
+            </a:r>
+            <a:endParaRPr lang="en-US" sz="2000" b="0" u="none" strike="noStrike">
+              <a:solidFill>
+                <a:schemeClr val="dk1"/>
+              </a:solidFill>
+              <a:effectLst/>
+              <a:uFillTx/>
+              <a:latin typeface="Calibri"/>
+            </a:endParaRPr>
+          </a:p>
+          <a:p>
+            <a:pPr marL="3024000" lvl="6" indent="-216000" algn="l" defTabSz="457200">
+              <a:lnSpc>
+                <a:spcPct val="100000"/>
+              </a:lnSpc>
+              <a:spcBef>
+                <a:spcPts val="283"/>
+              </a:spcBef>
+              <a:buClr>
+                <a:srgbClr val="000000"/>
+              </a:buClr>
+              <a:buSzPct val="45000"/>
+              <a:buFont typeface="Wingdings" charset="2"/>
+              <a:buChar char=""/>
+            </a:pPr>
+            <a:r>
+              <a:rPr lang="en-US" sz="2000" b="0" u="none" strike="noStrike">
+                <a:solidFill>
+                  <a:schemeClr val="dk1"/>
+                </a:solidFill>
+                <a:effectLst/>
+                <a:uFillTx/>
+                <a:latin typeface="Calibri"/>
+              </a:rPr>
+              <a:t>Seventh Outline Level</a:t>
+            </a:r>
+            <a:endParaRPr lang="en-US" sz="2000" b="0" u="none" strike="noStrike">
+              <a:solidFill>
+                <a:schemeClr val="dk1"/>
+              </a:solidFill>
+              <a:effectLst/>
+              <a:uFillTx/>
+              <a:latin typeface="Calibri"/>
+            </a:endParaRPr>
+          </a:p>
+        </p:txBody>
+      </p:sp>
+    </p:spTree>
+  </p:cSld>
+</p:sldLayout>
+</file>
+
+<file path=ppt/slideLayouts/slideLayout8.xml><?xml version="1.0" encoding="utf-8"?>
+<p:sldLayout xmlns:a="http://schemas.openxmlformats.org/drawingml/2006/main" xmlns:p="http://schemas.openxmlformats.org/presentationml/2006/main" xmlns:r="http://schemas.openxmlformats.org/officeDocument/2006/relationships" xmlns:p14="http://schemas.microsoft.com/office/powerpoint/2010/main" xmlns:p15="http://schemas.microsoft.com/office/powerpoint/2012/main" xmlns:mc="http://schemas.openxmlformats.org/markup-compatibility/2006" type="blank" preserve="1">
+  <p:cSld name="Content with Caption">
+    <p:bg>
+      <p:bgPr>
+        <a:solidFill>
+          <a:srgbClr val="FFFFFF"/>
+        </a:solidFill>
+      </p:bgPr>
+    </p:bg>
+    <p:spTree>
+      <p:nvGrpSpPr>
+        <p:cNvPr id="1" name=""/>
+        <p:cNvGrpSpPr/>
+        <p:nvPr/>
+      </p:nvGrpSpPr>
+      <p:grpSpPr>
+        <a:xfrm>
+          <a:off x="0" y="0"/>
+          <a:ext cx="0" cy="0"/>
+          <a:chOff x="0" y="0"/>
+          <a:chExt cx="0" cy="0"/>
+        </a:xfrm>
+      </p:grpSpPr>
+      <p:sp>
+        <p:nvSpPr>
+          <p:cNvPr id="40" name="PlaceHolder 1"/>
+          <p:cNvSpPr>
+            <a:spLocks noGrp="1"/>
+          </p:cNvSpPr>
+          <p:nvPr>
             <p:ph type="title"/>
           </p:nvPr>
         </p:nvSpPr>
         <p:spPr>
           <a:xfrm>
             <a:off x="457200" y="272880"/>
-            <a:ext cx="3004200" cy="1158120"/>
+            <a:ext cx="3002760" cy="1156680"/>
           </a:xfrm>
           <a:prstGeom prst="rect">
             <a:avLst/>
@@ -5872,7 +6199,29 @@
                 <a:uFillTx/>
                 <a:latin typeface="Calibri"/>
               </a:rPr>
-              <a:t>Click to edit Master title style</a:t>
+              <a:t>Click to edit </a:t>
+            </a:r>
+            <a:r>
+              <a:rPr lang="en-US" sz="2000" b="1" u="none" strike="noStrike">
+                <a:solidFill>
+                  <a:schemeClr val="dk1"/>
+                </a:solidFill>
+                <a:effectLst/>
+                <a:uFillTx/>
+                <a:latin typeface="Calibri"/>
+              </a:rPr>
+              <a:t>Master title </a:t>
+            </a:r>
+            <a:r>
+              <a:rPr lang="en-US" sz="2000" b="1" u="none" strike="noStrike">
+                <a:solidFill>
+                  <a:schemeClr val="dk1"/>
+                </a:solidFill>
+                <a:effectLst/>
+                <a:uFillTx/>
+                <a:latin typeface="Calibri"/>
+              </a:rPr>
+              <a:t>style</a:t>
             </a:r>
             <a:endParaRPr lang="en-US" sz="2000" b="1" u="none" strike="noStrike">
               <a:solidFill>
@@ -5887,7 +6236,7 @@
       </p:sp>
       <p:sp>
         <p:nvSpPr>
-          <p:cNvPr id="36" name="PlaceHolder 2"/>
+          <p:cNvPr id="41" name="PlaceHolder 2"/>
           <p:cNvSpPr>
             <a:spLocks noGrp="1"/>
           </p:cNvSpPr>
@@ -5898,7 +6247,7 @@
         <p:spPr>
           <a:xfrm>
             <a:off x="3575160" y="272880"/>
-            <a:ext cx="5107680" cy="5849280"/>
+            <a:ext cx="5106240" cy="5847840"/>
           </a:xfrm>
           <a:prstGeom prst="rect">
             <a:avLst/>
@@ -6193,7 +6542,7 @@
       </p:sp>
       <p:sp>
         <p:nvSpPr>
-          <p:cNvPr id="37" name="PlaceHolder 3"/>
+          <p:cNvPr id="42" name="PlaceHolder 3"/>
           <p:cNvSpPr>
             <a:spLocks noGrp="1"/>
           </p:cNvSpPr>
@@ -6204,7 +6553,7 @@
         <p:spPr>
           <a:xfrm>
             <a:off x="457200" y="1434960"/>
-            <a:ext cx="3004200" cy="4687200"/>
+            <a:ext cx="3002760" cy="4685760"/>
           </a:xfrm>
           <a:prstGeom prst="rect">
             <a:avLst/>
@@ -6277,18 +6626,18 @@
       </p:sp>
       <p:sp>
         <p:nvSpPr>
-          <p:cNvPr id="38" name="PlaceHolder 4"/>
+          <p:cNvPr id="43" name="PlaceHolder 4"/>
           <p:cNvSpPr>
             <a:spLocks noGrp="1"/>
           </p:cNvSpPr>
           <p:nvPr>
-            <p:ph type="dt" idx="19"/>
+            <p:ph type="dt" idx="22"/>
           </p:nvPr>
         </p:nvSpPr>
         <p:spPr>
           <a:xfrm>
             <a:off x="457200" y="6356520"/>
-            <a:ext cx="2129760" cy="361080"/>
+            <a:ext cx="2128320" cy="359640"/>
           </a:xfrm>
           <a:prstGeom prst="rect">
             <a:avLst/>
@@ -6359,18 +6708,18 @@
       </p:sp>
       <p:sp>
         <p:nvSpPr>
-          <p:cNvPr id="39" name="PlaceHolder 5"/>
+          <p:cNvPr id="44" name="PlaceHolder 5"/>
           <p:cNvSpPr>
             <a:spLocks noGrp="1"/>
           </p:cNvSpPr>
           <p:nvPr>
-            <p:ph type="ftr" idx="20"/>
+            <p:ph type="ftr" idx="23"/>
           </p:nvPr>
         </p:nvSpPr>
         <p:spPr>
           <a:xfrm>
             <a:off x="3124080" y="6356520"/>
-            <a:ext cx="2891520" cy="361080"/>
+            <a:ext cx="2890080" cy="359640"/>
           </a:xfrm>
           <a:prstGeom prst="rect">
             <a:avLst/>
@@ -6437,18 +6786,18 @@
       </p:sp>
       <p:sp>
         <p:nvSpPr>
-          <p:cNvPr id="40" name="PlaceHolder 6"/>
+          <p:cNvPr id="45" name="PlaceHolder 6"/>
           <p:cNvSpPr>
             <a:spLocks noGrp="1"/>
           </p:cNvSpPr>
           <p:nvPr>
-            <p:ph type="sldNum" idx="21"/>
+            <p:ph type="sldNum" idx="24"/>
           </p:nvPr>
         </p:nvSpPr>
         <p:spPr>
           <a:xfrm>
             <a:off x="6553080" y="6356520"/>
-            <a:ext cx="2129760" cy="361080"/>
+            <a:ext cx="2128320" cy="359640"/>
           </a:xfrm>
           <a:prstGeom prst="rect">
             <a:avLst/>
@@ -6493,7 +6842,7 @@
                 <a:tab pos="0" algn="l"/>
               </a:tabLst>
             </a:pPr>
-            <a:fld id="{4F0771F5-D1DE-4084-86F6-933AC79C3F68}" type="slidenum">
+            <a:fld id="{9F8A68FD-2E11-4E44-A4AA-A0C5194B0EA3}" type="slidenum">
               <a:rPr lang="en-US" sz="1200" b="0" u="none" strike="noStrike">
                 <a:solidFill>
                   <a:schemeClr val="dk1">
@@ -6522,7 +6871,7 @@
 </p:sldLayout>
 </file>
 
-<file path=ppt/slideLayouts/slideLayout8.xml><?xml version="1.0" encoding="utf-8"?>
+<file path=ppt/slideLayouts/slideLayout9.xml><?xml version="1.0" encoding="utf-8"?>
 <p:sldLayout xmlns:a="http://schemas.openxmlformats.org/drawingml/2006/main" xmlns:p="http://schemas.openxmlformats.org/presentationml/2006/main" xmlns:r="http://schemas.openxmlformats.org/officeDocument/2006/relationships" xmlns:p14="http://schemas.microsoft.com/office/powerpoint/2010/main" xmlns:p15="http://schemas.microsoft.com/office/powerpoint/2012/main" xmlns:mc="http://schemas.openxmlformats.org/markup-compatibility/2006" type="blank" preserve="1">
   <p:cSld name="Picture with Caption">
     <p:bg>
@@ -6548,7 +6897,7 @@
       </p:grpSpPr>
       <p:sp>
         <p:nvSpPr>
-          <p:cNvPr id="41" name="PlaceHolder 1"/>
+          <p:cNvPr id="46" name="PlaceHolder 1"/>
           <p:cNvSpPr>
             <a:spLocks noGrp="1"/>
           </p:cNvSpPr>
@@ -6559,7 +6908,7 @@
         <p:spPr>
           <a:xfrm>
             <a:off x="1792440" y="4800600"/>
-            <a:ext cx="5482440" cy="562680"/>
+            <a:ext cx="5481000" cy="561240"/>
           </a:xfrm>
           <a:prstGeom prst="rect">
             <a:avLst/>
@@ -6626,7 +6975,7 @@
       </p:sp>
       <p:sp>
         <p:nvSpPr>
-          <p:cNvPr id="42" name="PlaceHolder 2"/>
+          <p:cNvPr id="47" name="PlaceHolder 2"/>
           <p:cNvSpPr>
             <a:spLocks noGrp="1"/>
           </p:cNvSpPr>
@@ -6637,7 +6986,7 @@
         <p:spPr>
           <a:xfrm>
             <a:off x="1792440" y="612720"/>
-            <a:ext cx="5482440" cy="4110840"/>
+            <a:ext cx="5481000" cy="4109400"/>
           </a:xfrm>
           <a:prstGeom prst="rect">
             <a:avLst/>
@@ -7096,7 +7445,7 @@
       </p:sp>
       <p:sp>
         <p:nvSpPr>
-          <p:cNvPr id="43" name="PlaceHolder 3"/>
+          <p:cNvPr id="48" name="PlaceHolder 3"/>
           <p:cNvSpPr>
             <a:spLocks noGrp="1"/>
           </p:cNvSpPr>
@@ -7107,7 +7456,7 @@
         <p:spPr>
           <a:xfrm>
             <a:off x="1792440" y="5367240"/>
-            <a:ext cx="5482440" cy="801000"/>
+            <a:ext cx="5481000" cy="799560"/>
           </a:xfrm>
           <a:prstGeom prst="rect">
             <a:avLst/>
@@ -7180,18 +7529,18 @@
       </p:sp>
       <p:sp>
         <p:nvSpPr>
-          <p:cNvPr id="44" name="PlaceHolder 4"/>
+          <p:cNvPr id="49" name="PlaceHolder 4"/>
           <p:cNvSpPr>
             <a:spLocks noGrp="1"/>
           </p:cNvSpPr>
           <p:nvPr>
-            <p:ph type="dt" idx="22"/>
+            <p:ph type="dt" idx="25"/>
           </p:nvPr>
         </p:nvSpPr>
         <p:spPr>
           <a:xfrm>
             <a:off x="457200" y="6356520"/>
-            <a:ext cx="2129760" cy="361080"/>
+            <a:ext cx="2128320" cy="359640"/>
           </a:xfrm>
           <a:prstGeom prst="rect">
             <a:avLst/>
@@ -7262,18 +7611,18 @@
       </p:sp>
       <p:sp>
         <p:nvSpPr>
-          <p:cNvPr id="45" name="PlaceHolder 5"/>
+          <p:cNvPr id="50" name="PlaceHolder 5"/>
           <p:cNvSpPr>
             <a:spLocks noGrp="1"/>
           </p:cNvSpPr>
           <p:nvPr>
-            <p:ph type="ftr" idx="23"/>
+            <p:ph type="ftr" idx="26"/>
           </p:nvPr>
         </p:nvSpPr>
         <p:spPr>
           <a:xfrm>
             <a:off x="3124080" y="6356520"/>
-            <a:ext cx="2891520" cy="361080"/>
+            <a:ext cx="2890080" cy="359640"/>
           </a:xfrm>
           <a:prstGeom prst="rect">
             <a:avLst/>
@@ -7340,18 +7689,18 @@
       </p:sp>
       <p:sp>
         <p:nvSpPr>
-          <p:cNvPr id="46" name="PlaceHolder 6"/>
+          <p:cNvPr id="51" name="PlaceHolder 6"/>
           <p:cNvSpPr>
             <a:spLocks noGrp="1"/>
           </p:cNvSpPr>
           <p:nvPr>
-            <p:ph type="sldNum" idx="24"/>
+            <p:ph type="sldNum" idx="27"/>
           </p:nvPr>
         </p:nvSpPr>
         <p:spPr>
           <a:xfrm>
             <a:off x="6553080" y="6356520"/>
-            <a:ext cx="2129760" cy="361080"/>
+            <a:ext cx="2128320" cy="359640"/>
           </a:xfrm>
           <a:prstGeom prst="rect">
             <a:avLst/>
@@ -7396,356 +7745,7 @@
                 <a:tab pos="0" algn="l"/>
               </a:tabLst>
             </a:pPr>
-            <a:fld id="{B9CFB4B8-120D-4AE5-954A-FB4CD2A86D6D}" type="slidenum">
-              <a:rPr lang="en-US" sz="1200" b="0" u="none" strike="noStrike">
-                <a:solidFill>
-                  <a:schemeClr val="dk1">
-                    <a:tint val="75000"/>
-                  </a:schemeClr>
-                </a:solidFill>
-                <a:effectLst/>
-                <a:uFillTx/>
-                <a:latin typeface="Calibri"/>
-              </a:rPr>
-              <a:t>&lt;number&gt;</a:t>
-            </a:fld>
-            <a:endParaRPr lang="en-US" sz="1200" b="0" u="none" strike="noStrike">
-              <a:solidFill>
-                <a:srgbClr val="000000"/>
-              </a:solidFill>
-              <a:effectLst/>
-              <a:uFillTx/>
-              <a:latin typeface="Times New Roman"/>
-            </a:endParaRPr>
-          </a:p>
-        </p:txBody>
-      </p:sp>
-    </p:spTree>
-  </p:cSld>
-</p:sldLayout>
-</file>
-
-<file path=ppt/slideLayouts/slideLayout9.xml><?xml version="1.0" encoding="utf-8"?>
-<p:sldLayout xmlns:a="http://schemas.openxmlformats.org/drawingml/2006/main" xmlns:p="http://schemas.openxmlformats.org/presentationml/2006/main" xmlns:r="http://schemas.openxmlformats.org/officeDocument/2006/relationships" xmlns:p14="http://schemas.microsoft.com/office/powerpoint/2010/main" xmlns:p15="http://schemas.microsoft.com/office/powerpoint/2012/main" xmlns:mc="http://schemas.openxmlformats.org/markup-compatibility/2006" type="title" preserve="1">
-  <p:cSld name="Title Slide">
-    <p:bg>
-      <p:bgPr>
-        <a:solidFill>
-          <a:srgbClr val="FFFFFF"/>
-        </a:solidFill>
-      </p:bgPr>
-    </p:bg>
-    <p:spTree>
-      <p:nvGrpSpPr>
-        <p:cNvPr id="1" name=""/>
-        <p:cNvGrpSpPr/>
-        <p:nvPr/>
-      </p:nvGrpSpPr>
-      <p:grpSpPr>
-        <a:xfrm>
-          <a:off x="0" y="0"/>
-          <a:ext cx="0" cy="0"/>
-          <a:chOff x="0" y="0"/>
-          <a:chExt cx="0" cy="0"/>
-        </a:xfrm>
-      </p:grpSpPr>
-      <p:sp>
-        <p:nvSpPr>
-          <p:cNvPr id="47" name="PlaceHolder 1"/>
-          <p:cNvSpPr>
-            <a:spLocks noGrp="1"/>
-          </p:cNvSpPr>
-          <p:nvPr>
-            <p:ph type="title"/>
-          </p:nvPr>
-        </p:nvSpPr>
-        <p:spPr>
-          <a:xfrm>
-            <a:off x="685800" y="2130480"/>
-            <a:ext cx="7768440" cy="1465920"/>
-          </a:xfrm>
-          <a:prstGeom prst="rect">
-            <a:avLst/>
-          </a:prstGeom>
-          <a:noFill/>
-          <a:ln w="0">
-            <a:noFill/>
-          </a:ln>
-        </p:spPr>
-        <p:txBody>
-          <a:bodyPr lIns="91440" tIns="45720" rIns="91440" bIns="45720" anchor="ctr">
-            <a:noAutofit/>
-          </a:bodyPr>
-          <a:lstStyle>
-            <a:lvl1pPr indent="0" algn="ctr" defTabSz="457200">
-              <a:lnSpc>
-                <a:spcPct val="100000"/>
-              </a:lnSpc>
-              <a:buNone/>
-              <a:tabLst>
-                <a:tab pos="0" algn="l"/>
-              </a:tabLst>
-              <a:defRPr lang="en-US" sz="4400" b="0" u="none" strike="noStrike">
-                <a:solidFill>
-                  <a:schemeClr val="dk1"/>
-                </a:solidFill>
-                <a:effectLst/>
-                <a:uFillTx/>
-                <a:latin typeface="Calibri"/>
-              </a:defRPr>
-            </a:lvl1pPr>
-          </a:lstStyle>
-          <a:p>
-            <a:pPr indent="0" algn="ctr" defTabSz="457200">
-              <a:lnSpc>
-                <a:spcPct val="100000"/>
-              </a:lnSpc>
-              <a:buNone/>
-              <a:tabLst>
-                <a:tab pos="0" algn="l"/>
-              </a:tabLst>
-            </a:pPr>
-            <a:r>
-              <a:rPr lang="en-US" sz="4400" b="0" u="none" strike="noStrike">
-                <a:solidFill>
-                  <a:schemeClr val="dk1"/>
-                </a:solidFill>
-                <a:effectLst/>
-                <a:uFillTx/>
-                <a:latin typeface="Calibri"/>
-              </a:rPr>
-              <a:t>Click to edit Master title style</a:t>
-            </a:r>
-            <a:endParaRPr lang="en-US" sz="4400" b="0" u="none" strike="noStrike">
-              <a:solidFill>
-                <a:schemeClr val="dk1"/>
-              </a:solidFill>
-              <a:effectLst/>
-              <a:uFillTx/>
-              <a:latin typeface="Calibri"/>
-            </a:endParaRPr>
-          </a:p>
-        </p:txBody>
-      </p:sp>
-      <p:sp>
-        <p:nvSpPr>
-          <p:cNvPr id="48" name="PlaceHolder 2"/>
-          <p:cNvSpPr>
-            <a:spLocks noGrp="1"/>
-          </p:cNvSpPr>
-          <p:nvPr>
-            <p:ph type="dt" idx="25"/>
-          </p:nvPr>
-        </p:nvSpPr>
-        <p:spPr>
-          <a:xfrm>
-            <a:off x="457200" y="6356520"/>
-            <a:ext cx="2129760" cy="361080"/>
-          </a:xfrm>
-          <a:prstGeom prst="rect">
-            <a:avLst/>
-          </a:prstGeom>
-          <a:noFill/>
-          <a:ln w="0">
-            <a:noFill/>
-          </a:ln>
-        </p:spPr>
-        <p:txBody>
-          <a:bodyPr lIns="91440" tIns="45720" rIns="91440" bIns="45720" anchor="ctr">
-            <a:noAutofit/>
-          </a:bodyPr>
-          <a:lstStyle>
-            <a:lvl1pPr indent="0" algn="l" defTabSz="457200">
-              <a:lnSpc>
-                <a:spcPct val="100000"/>
-              </a:lnSpc>
-              <a:buNone/>
-              <a:tabLst>
-                <a:tab pos="0" algn="l"/>
-              </a:tabLst>
-              <a:defRPr lang="en-US" sz="1200" b="0" u="none" strike="noStrike">
-                <a:solidFill>
-                  <a:schemeClr val="dk1">
-                    <a:tint val="75000"/>
-                  </a:schemeClr>
-                </a:solidFill>
-                <a:effectLst/>
-                <a:uFillTx/>
-                <a:latin typeface="Calibri"/>
-              </a:defRPr>
-            </a:lvl1pPr>
-          </a:lstStyle>
-          <a:p>
-            <a:pPr indent="0" algn="l" defTabSz="457200">
-              <a:lnSpc>
-                <a:spcPct val="100000"/>
-              </a:lnSpc>
-              <a:buNone/>
-              <a:tabLst>
-                <a:tab pos="0" algn="l"/>
-              </a:tabLst>
-            </a:pPr>
-            <a:r>
-              <a:rPr lang="en-US" sz="1200" b="0" u="none" strike="noStrike">
-                <a:solidFill>
-                  <a:schemeClr val="dk1">
-                    <a:tint val="75000"/>
-                  </a:schemeClr>
-                </a:solidFill>
-                <a:effectLst/>
-                <a:uFillTx/>
-                <a:latin typeface="Calibri"/>
-              </a:rPr>
-              <a:t>&lt;date/time&gt;</a:t>
-            </a:r>
-            <a:endParaRPr lang="en-US" sz="1200" b="0" u="none" strike="noStrike">
-              <a:solidFill>
-                <a:srgbClr val="000000"/>
-              </a:solidFill>
-              <a:effectLst/>
-              <a:uFillTx/>
-              <a:latin typeface="Times New Roman"/>
-            </a:endParaRPr>
-          </a:p>
-        </p:txBody>
-      </p:sp>
-      <p:sp>
-        <p:nvSpPr>
-          <p:cNvPr id="49" name="PlaceHolder 3"/>
-          <p:cNvSpPr>
-            <a:spLocks noGrp="1"/>
-          </p:cNvSpPr>
-          <p:nvPr>
-            <p:ph type="ftr" idx="26"/>
-          </p:nvPr>
-        </p:nvSpPr>
-        <p:spPr>
-          <a:xfrm>
-            <a:off x="3124080" y="6356520"/>
-            <a:ext cx="2891520" cy="361080"/>
-          </a:xfrm>
-          <a:prstGeom prst="rect">
-            <a:avLst/>
-          </a:prstGeom>
-          <a:noFill/>
-          <a:ln w="0">
-            <a:noFill/>
-          </a:ln>
-        </p:spPr>
-        <p:txBody>
-          <a:bodyPr lIns="91440" tIns="45720" rIns="91440" bIns="45720" anchor="ctr">
-            <a:noAutofit/>
-          </a:bodyPr>
-          <a:lstStyle>
-            <a:lvl1pPr indent="0" algn="ctr">
-              <a:lnSpc>
-                <a:spcPct val="100000"/>
-              </a:lnSpc>
-              <a:buNone/>
-              <a:tabLst>
-                <a:tab pos="0" algn="l"/>
-              </a:tabLst>
-              <a:defRPr lang="en-US" sz="1400" b="0" u="none" strike="noStrike">
-                <a:solidFill>
-                  <a:srgbClr val="000000"/>
-                </a:solidFill>
-                <a:effectLst/>
-                <a:uFillTx/>
-                <a:latin typeface="Times New Roman"/>
-              </a:defRPr>
-            </a:lvl1pPr>
-          </a:lstStyle>
-          <a:p>
-            <a:pPr indent="0" algn="ctr">
-              <a:lnSpc>
-                <a:spcPct val="100000"/>
-              </a:lnSpc>
-              <a:buNone/>
-              <a:tabLst>
-                <a:tab pos="0" algn="l"/>
-              </a:tabLst>
-            </a:pPr>
-            <a:r>
-              <a:rPr lang="en-US" sz="1400" b="0" u="none" strike="noStrike">
-                <a:solidFill>
-                  <a:srgbClr val="000000"/>
-                </a:solidFill>
-                <a:effectLst/>
-                <a:uFillTx/>
-                <a:latin typeface="Times New Roman"/>
-              </a:rPr>
-              <a:t>&lt;footer&gt;</a:t>
-            </a:r>
-            <a:endParaRPr lang="en-US" sz="1400" b="0" u="none" strike="noStrike">
-              <a:solidFill>
-                <a:srgbClr val="000000"/>
-              </a:solidFill>
-              <a:effectLst/>
-              <a:uFillTx/>
-              <a:latin typeface="Times New Roman"/>
-            </a:endParaRPr>
-          </a:p>
-        </p:txBody>
-      </p:sp>
-      <p:sp>
-        <p:nvSpPr>
-          <p:cNvPr id="50" name="PlaceHolder 4"/>
-          <p:cNvSpPr>
-            <a:spLocks noGrp="1"/>
-          </p:cNvSpPr>
-          <p:nvPr>
-            <p:ph type="sldNum" idx="27"/>
-          </p:nvPr>
-        </p:nvSpPr>
-        <p:spPr>
-          <a:xfrm>
-            <a:off x="6553080" y="6356520"/>
-            <a:ext cx="2129760" cy="361080"/>
-          </a:xfrm>
-          <a:prstGeom prst="rect">
-            <a:avLst/>
-          </a:prstGeom>
-          <a:noFill/>
-          <a:ln w="0">
-            <a:noFill/>
-          </a:ln>
-        </p:spPr>
-        <p:txBody>
-          <a:bodyPr lIns="91440" tIns="45720" rIns="91440" bIns="45720" anchor="ctr">
-            <a:noAutofit/>
-          </a:bodyPr>
-          <a:lstStyle>
-            <a:lvl1pPr indent="0" algn="r" defTabSz="457200">
-              <a:lnSpc>
-                <a:spcPct val="100000"/>
-              </a:lnSpc>
-              <a:buNone/>
-              <a:tabLst>
-                <a:tab pos="0" algn="l"/>
-              </a:tabLst>
-              <a:defRPr lang="en-US" sz="1200" b="0" u="none" strike="noStrike">
-                <a:solidFill>
-                  <a:schemeClr val="dk1">
-                    <a:tint val="75000"/>
-                  </a:schemeClr>
-                </a:solidFill>
-                <a:effectLst/>
-                <a:uFillTx/>
-                <a:latin typeface="Calibri"/>
-              </a:defRPr>
-            </a:lvl1pPr>
-          </a:lstStyle>
-          <a:p>
-            <a:pPr indent="0" algn="r" defTabSz="457200">
-              <a:lnSpc>
-                <a:spcPct val="100000"/>
-              </a:lnSpc>
-              <a:buNone/>
-              <a:tabLst>
-                <a:tab pos="0" algn="l"/>
-              </a:tabLst>
-            </a:pPr>
-            <a:fld id="{1F7E66AF-CEE6-4D29-9F33-837007D47A36}" type="slidenum">
+            <a:fld id="{98C078F0-731D-4526-B57F-2BB7C33B14C9}" type="slidenum">
               <a:rPr lang="en-US" sz="1200" b="0" u="none" strike="noStrike">
                 <a:solidFill>
                   <a:schemeClr val="dk1">
@@ -7836,7 +7836,7 @@
         <p:spPr>
           <a:xfrm>
             <a:off x="0" y="0"/>
-            <a:ext cx="12187800" cy="160560"/>
+            <a:ext cx="12186360" cy="159120"/>
           </a:xfrm>
           <a:prstGeom prst="rect">
             <a:avLst/>
@@ -7892,7 +7892,7 @@
         <p:spPr>
           <a:xfrm>
             <a:off x="731520" y="1828800"/>
-            <a:ext cx="10694520" cy="910440"/>
+            <a:ext cx="10693080" cy="607680"/>
           </a:xfrm>
           <a:prstGeom prst="rect">
             <a:avLst/>
@@ -7917,6 +7917,12 @@
               <a:lnSpc>
                 <a:spcPct val="100000"/>
               </a:lnSpc>
+              <a:spcBef>
+                <a:spcPts val="1191"/>
+              </a:spcBef>
+              <a:spcAft>
+                <a:spcPts val="992"/>
+              </a:spcAft>
             </a:pPr>
             <a:r>
               <a:rPr lang="en-US" sz="3400" b="1" u="none" strike="noStrike">
@@ -7949,7 +7955,7 @@
         <p:spPr>
           <a:xfrm>
             <a:off x="731520" y="2880360"/>
-            <a:ext cx="10694520" cy="544680"/>
+            <a:ext cx="10693080" cy="821160"/>
           </a:xfrm>
           <a:prstGeom prst="rect">
             <a:avLst/>
@@ -7974,6 +7980,12 @@
               <a:lnSpc>
                 <a:spcPct val="100000"/>
               </a:lnSpc>
+              <a:spcBef>
+                <a:spcPts val="1191"/>
+              </a:spcBef>
+              <a:spcAft>
+                <a:spcPts val="992"/>
+              </a:spcAft>
             </a:pPr>
             <a:r>
               <a:rPr lang="en-US" sz="2400" b="0" u="none" strike="noStrike">
@@ -7984,7 +7996,7 @@
                 <a:uFillTx/>
                 <a:latin typeface="Calibri"/>
               </a:rPr>
-              <a:t>{{company.name}}</a:t>
+              <a:t>{{textColor:report.textColor}}{{bgColor:report.bgColor}}{{company.name}}</a:t>
             </a:r>
             <a:endParaRPr lang="en-US" sz="2400" b="0" u="none" strike="noStrike">
               <a:solidFill>
@@ -8006,7 +8018,7 @@
         <p:spPr>
           <a:xfrm>
             <a:off x="731520" y="5303520"/>
-            <a:ext cx="10694520" cy="453240"/>
+            <a:ext cx="10693080" cy="333360"/>
           </a:xfrm>
           <a:prstGeom prst="rect">
             <a:avLst/>
@@ -8093,7 +8105,7 @@
         <p:spPr>
           <a:xfrm>
             <a:off x="0" y="0"/>
-            <a:ext cx="12187800" cy="160560"/>
+            <a:ext cx="12186360" cy="159120"/>
           </a:xfrm>
           <a:prstGeom prst="rect">
             <a:avLst/>
@@ -8149,7 +8161,7 @@
         <p:spPr>
           <a:xfrm>
             <a:off x="640080" y="411480"/>
-            <a:ext cx="10877400" cy="544680"/>
+            <a:ext cx="10875960" cy="543240"/>
           </a:xfrm>
           <a:prstGeom prst="rect">
             <a:avLst/>
@@ -8206,7 +8218,7 @@
         <p:spPr>
           <a:xfrm>
             <a:off x="786960" y="1191600"/>
-            <a:ext cx="2007720" cy="407520"/>
+            <a:ext cx="2006280" cy="406080"/>
           </a:xfrm>
           <a:prstGeom prst="rect">
             <a:avLst/>
@@ -8263,7 +8275,7 @@
         <p:spPr>
           <a:xfrm>
             <a:off x="2707200" y="1191600"/>
-            <a:ext cx="7768440" cy="407520"/>
+            <a:ext cx="7767000" cy="363960"/>
           </a:xfrm>
           <a:prstGeom prst="rect">
             <a:avLst/>
@@ -8320,7 +8332,7 @@
         <p:spPr>
           <a:xfrm>
             <a:off x="786960" y="1529280"/>
-            <a:ext cx="2007720" cy="407520"/>
+            <a:ext cx="2006280" cy="406080"/>
           </a:xfrm>
           <a:prstGeom prst="rect">
             <a:avLst/>
@@ -8377,7 +8389,7 @@
         <p:spPr>
           <a:xfrm>
             <a:off x="2671200" y="1493280"/>
-            <a:ext cx="7768440" cy="407520"/>
+            <a:ext cx="7767000" cy="363960"/>
           </a:xfrm>
           <a:prstGeom prst="rect">
             <a:avLst/>
@@ -8434,7 +8446,7 @@
         <p:spPr>
           <a:xfrm>
             <a:off x="786960" y="1852920"/>
-            <a:ext cx="2007720" cy="407520"/>
+            <a:ext cx="2006280" cy="406080"/>
           </a:xfrm>
           <a:prstGeom prst="rect">
             <a:avLst/>
@@ -8491,7 +8503,7 @@
         <p:spPr>
           <a:xfrm>
             <a:off x="2671200" y="1816920"/>
-            <a:ext cx="7768440" cy="407520"/>
+            <a:ext cx="7767000" cy="363960"/>
           </a:xfrm>
           <a:prstGeom prst="rect">
             <a:avLst/>
@@ -8547,7 +8559,7 @@
         </p:nvGraphicFramePr>
         <p:xfrm>
           <a:off x="781560" y="3515400"/>
-          <a:ext cx="8686440" cy="893880"/>
+          <a:ext cx="8686440" cy="1030320"/>
         </p:xfrm>
         <a:graphic>
           <a:graphicData uri="http://schemas.openxmlformats.org/drawingml/2006/table">
@@ -8953,7 +8965,7 @@
                           <a:uFillTx/>
                           <a:latin typeface="Calibri"/>
                         </a:rPr>
-                        <a:t>{{status}}</a:t>
+                        <a:t>{{bgColor:statusColor}}{{status}}</a:t>
                       </a:r>
                       <a:endParaRPr lang="en-US" sz="1600" b="0" u="none" strike="noStrike">
                         <a:solidFill>
@@ -9167,7 +9179,7 @@
         <p:spPr>
           <a:xfrm>
             <a:off x="0" y="0"/>
-            <a:ext cx="12187800" cy="160560"/>
+            <a:ext cx="12186360" cy="159120"/>
           </a:xfrm>
           <a:prstGeom prst="rect">
             <a:avLst/>
@@ -9223,14 +9235,12 @@
         <p:spPr>
           <a:xfrm>
             <a:off x="640080" y="411480"/>
-            <a:ext cx="2246040" cy="516600"/>
+            <a:ext cx="2246760" cy="516600"/>
           </a:xfrm>
           <a:prstGeom prst="rect">
             <a:avLst/>
           </a:prstGeom>
-          <a:solidFill>
-            <a:srgbClr val="81D41A"/>
-          </a:solidFill>
+          <a:noFill/>
           <a:ln w="0">
             <a:noFill/>
           </a:ln>
@@ -9260,7 +9270,18 @@
                 <a:uFillTx/>
                 <a:latin typeface="Calibri"/>
               </a:rPr>
-              <a:t>Risk Details</a:t>
+              <a:t>Risk </a:t>
+            </a:r>
+            <a:r>
+              <a:rPr lang="en-US" sz="2800" b="1" u="none" strike="noStrike">
+                <a:solidFill>
+                  <a:schemeClr val="dk1"/>
+                </a:solidFill>
+                <a:effectLst/>
+                <a:uFillTx/>
+                <a:latin typeface="Calibri"/>
+              </a:rPr>
+              <a:t>Details</a:t>
             </a:r>
             <a:endParaRPr lang="en-US" sz="2800" b="0" u="none" strike="noStrike">
               <a:solidFill>
@@ -9282,7 +9303,7 @@
         <p:spPr>
           <a:xfrm>
             <a:off x="731520" y="1234440"/>
-            <a:ext cx="1824840" cy="272520"/>
+            <a:ext cx="1823400" cy="272520"/>
           </a:xfrm>
           <a:prstGeom prst="rect">
             <a:avLst/>
@@ -9339,7 +9360,7 @@
         <p:spPr>
           <a:xfrm>
             <a:off x="731520" y="1645920"/>
-            <a:ext cx="10237320" cy="409680"/>
+            <a:ext cx="5212080" cy="409680"/>
           </a:xfrm>
           <a:prstGeom prst="rect">
             <a:avLst/>
@@ -9364,6 +9385,12 @@
               <a:lnSpc>
                 <a:spcPct val="100000"/>
               </a:lnSpc>
+              <a:spcBef>
+                <a:spcPts val="1191"/>
+              </a:spcBef>
+              <a:spcAft>
+                <a:spcPts val="992"/>
+              </a:spcAft>
             </a:pPr>
             <a:r>
               <a:rPr lang="en-US" sz="2100" b="1" u="none" strike="noStrike">
@@ -9371,13 +9398,10 @@
                   <a:schemeClr val="dk1"/>
                 </a:solidFill>
                 <a:effectLst/>
-                <a:highlight>
-                  <a:srgbClr val="FFFF00"/>
-                </a:highlight>
-                <a:uFillTx/>
-                <a:latin typeface="Calibri"/>
-              </a:rPr>
-              <a:t>Risk: {{name}}</a:t>
+                <a:uFillTx/>
+                <a:latin typeface="Calibri"/>
+              </a:rPr>
+              <a:t>Risk: {{bgColor:statusColor}}{{name}}</a:t>
             </a:r>
             <a:endParaRPr lang="en-US" sz="2100" b="0" u="none" strike="noStrike">
               <a:solidFill>
@@ -9399,7 +9423,7 @@
         <p:spPr>
           <a:xfrm>
             <a:off x="731520" y="2240280"/>
-            <a:ext cx="4568040" cy="348840"/>
+            <a:ext cx="4566600" cy="348840"/>
           </a:xfrm>
           <a:prstGeom prst="rect">
             <a:avLst/>
@@ -9458,7 +9482,7 @@
         <p:spPr>
           <a:xfrm>
             <a:off x="6126480" y="2240280"/>
-            <a:ext cx="4568040" cy="348840"/>
+            <a:ext cx="4566600" cy="348840"/>
           </a:xfrm>
           <a:prstGeom prst="rect">
             <a:avLst/>
@@ -9495,7 +9519,7 @@
                 <a:uFillTx/>
                 <a:latin typeface="Calibri"/>
               </a:rPr>
-              <a:t>Status: {{status}}</a:t>
+              <a:t>Status: {{textColor:statusColor}}{{status}}</a:t>
             </a:r>
             <a:endParaRPr lang="en-US" sz="1700" b="0" u="none" strike="noStrike">
               <a:solidFill>
@@ -9517,7 +9541,7 @@
         <p:spPr>
           <a:xfrm>
             <a:off x="731520" y="2926080"/>
-            <a:ext cx="2739240" cy="333360"/>
+            <a:ext cx="2737800" cy="333360"/>
           </a:xfrm>
           <a:prstGeom prst="rect">
             <a:avLst/>
@@ -9574,7 +9598,7 @@
         <p:spPr>
           <a:xfrm>
             <a:off x="731520" y="3383280"/>
-            <a:ext cx="10237320" cy="333360"/>
+            <a:ext cx="10235880" cy="333360"/>
           </a:xfrm>
           <a:prstGeom prst="rect">
             <a:avLst/>
@@ -9633,7 +9657,7 @@
         <p:spPr>
           <a:xfrm>
             <a:off x="731520" y="4434840"/>
-            <a:ext cx="2739240" cy="272520"/>
+            <a:ext cx="2737800" cy="272520"/>
           </a:xfrm>
           <a:prstGeom prst="rect">
             <a:avLst/>
@@ -9690,7 +9714,7 @@
         <p:spPr>
           <a:xfrm>
             <a:off x="731520" y="4800600"/>
-            <a:ext cx="10237320" cy="333360"/>
+            <a:ext cx="10235880" cy="333360"/>
           </a:xfrm>
           <a:prstGeom prst="rect">
             <a:avLst/>
@@ -9749,7 +9773,7 @@
         <p:spPr>
           <a:xfrm>
             <a:off x="731520" y="5486400"/>
-            <a:ext cx="1824840" cy="272520"/>
+            <a:ext cx="1823400" cy="272520"/>
           </a:xfrm>
           <a:prstGeom prst="rect">
             <a:avLst/>
@@ -9806,7 +9830,7 @@
         <p:spPr>
           <a:xfrm>
             <a:off x="2743200" y="5486400"/>
-            <a:ext cx="5482440" cy="318240"/>
+            <a:ext cx="5481000" cy="318240"/>
           </a:xfrm>
           <a:prstGeom prst="rect">
             <a:avLst/>
@@ -9863,7 +9887,7 @@
         <p:spPr>
           <a:xfrm>
             <a:off x="731520" y="5897880"/>
-            <a:ext cx="1824840" cy="272520"/>
+            <a:ext cx="1823400" cy="272520"/>
           </a:xfrm>
           <a:prstGeom prst="rect">
             <a:avLst/>
@@ -9920,7 +9944,7 @@
         <p:spPr>
           <a:xfrm>
             <a:off x="731520" y="6263640"/>
-            <a:ext cx="1824840" cy="272520"/>
+            <a:ext cx="1823400" cy="272520"/>
           </a:xfrm>
           <a:prstGeom prst="rect">
             <a:avLst/>
@@ -10007,7 +10031,7 @@
         <p:spPr>
           <a:xfrm>
             <a:off x="0" y="0"/>
-            <a:ext cx="12187800" cy="160560"/>
+            <a:ext cx="12186360" cy="159120"/>
           </a:xfrm>
           <a:prstGeom prst="rect">
             <a:avLst/>
@@ -10063,7 +10087,7 @@
         <p:spPr>
           <a:xfrm>
             <a:off x="640080" y="411480"/>
-            <a:ext cx="10877400" cy="544680"/>
+            <a:ext cx="10875960" cy="543240"/>
           </a:xfrm>
           <a:prstGeom prst="rect">
             <a:avLst/>
@@ -10120,7 +10144,7 @@
         <p:spPr>
           <a:xfrm>
             <a:off x="731520" y="1371600"/>
-            <a:ext cx="4568040" cy="316080"/>
+            <a:ext cx="4566600" cy="272520"/>
           </a:xfrm>
           <a:prstGeom prst="rect">
             <a:avLst/>
@@ -10177,7 +10201,7 @@
         <p:spPr>
           <a:xfrm>
             <a:off x="731520" y="1828800"/>
-            <a:ext cx="10054440" cy="544680"/>
+            <a:ext cx="10053000" cy="543240"/>
           </a:xfrm>
           <a:prstGeom prst="rect">
             <a:avLst/>
@@ -10234,7 +10258,7 @@
         <p:spPr>
           <a:xfrm>
             <a:off x="731520" y="2743200"/>
-            <a:ext cx="1824840" cy="316080"/>
+            <a:ext cx="1823400" cy="272520"/>
           </a:xfrm>
           <a:prstGeom prst="rect">
             <a:avLst/>
@@ -10291,7 +10315,7 @@
         <p:spPr>
           <a:xfrm>
             <a:off x="731520" y="3200400"/>
-            <a:ext cx="10054440" cy="544680"/>
+            <a:ext cx="10053000" cy="543240"/>
           </a:xfrm>
           <a:prstGeom prst="rect">
             <a:avLst/>
@@ -10348,7 +10372,7 @@
         <p:spPr>
           <a:xfrm>
             <a:off x="731520" y="4114800"/>
-            <a:ext cx="1824840" cy="316080"/>
+            <a:ext cx="1823400" cy="272520"/>
           </a:xfrm>
           <a:prstGeom prst="rect">
             <a:avLst/>
@@ -10405,7 +10429,7 @@
         <p:spPr>
           <a:xfrm>
             <a:off x="731520" y="5760720"/>
-            <a:ext cx="10054440" cy="361800"/>
+            <a:ext cx="10053000" cy="360360"/>
           </a:xfrm>
           <a:prstGeom prst="rect">
             <a:avLst/>

</xml_diff>